<commit_message>
chore(decks): regenerate all 321 teaching slide decks with updated generator
- All PPTX decks regenerated with latest generator script changes
- Includes zip base deck and audit script
- Updated .gitignore and deck generator scripts

Co-Authored-By: Claude Opus 4.6 (1M context) <noreply@anthropic.com>
</commit_message>
<xml_diff>
--- a/output/wordlabs-a-prefix-3day.pptx
+++ b/output/wordlabs-a-prefix-3day.pptx
@@ -4240,7 +4240,7 @@
                 <a:ea typeface="Calibri" pitchFamily="34" charset="-122"/>
                 <a:cs typeface="Calibri" pitchFamily="34" charset="-120"/>
               </a:rPr>
-              <a:t>"on, in, or into a state"</a:t>
+              <a:t>"not, without, on, toward"</a:t>
             </a:r>
             <a:endParaRPr lang="en-US" sz="2200" dirty="0"/>
           </a:p>
@@ -4279,7 +4279,7 @@
                 <a:ea typeface="Calibri" pitchFamily="34" charset="-122"/>
                 <a:cs typeface="Calibri" pitchFamily="34" charset="-120"/>
               </a:rPr>
-              <a:t>Origin: Old English: on</a:t>
+              <a:t>Origin: Greek: a- / Latin: ad- / Old English: on-</a:t>
             </a:r>
             <a:endParaRPr lang="en-US" sz="1300" dirty="0"/>
           </a:p>
@@ -5288,7 +5288,7 @@
                 <a:ea typeface="Calibri" pitchFamily="34" charset="-122"/>
                 <a:cs typeface="Calibri" pitchFamily="34" charset="-120"/>
               </a:rPr>
-              <a:t>Word Labs  •  wordlabs.app  •  Prefix: 'a-' = on, in, or into a state</a:t>
+              <a:t>Word Labs  •  wordlabs.app  •  Prefix: 'a-' = not, without, on, toward</a:t>
             </a:r>
             <a:endParaRPr lang="en-US" sz="800" dirty="0"/>
           </a:p>
@@ -5928,7 +5928,7 @@
                 <a:ea typeface="Calibri" pitchFamily="34" charset="-122"/>
                 <a:cs typeface="Calibri" pitchFamily="34" charset="-120"/>
               </a:rPr>
-              <a:t>Word Labs  •  wordlabs.app  •  Prefix: 'a-' = on, in, or into a state</a:t>
+              <a:t>Word Labs  •  wordlabs.app  •  Prefix: 'a-' = not, without, on, toward</a:t>
             </a:r>
             <a:endParaRPr lang="en-US" sz="800" dirty="0"/>
           </a:p>
@@ -6040,7 +6040,7 @@
                 <a:ea typeface="Calibri" pitchFamily="34" charset="-122"/>
                 <a:cs typeface="Calibri" pitchFamily="34" charset="-120"/>
               </a:rPr>
-              <a:t>The sailors were relieved to be </a:t>
+              <a:t>The children stayed </a:t>
             </a:r>
             <a:pPr algn="l" indent="0" marL="0">
               <a:buNone/>
@@ -6057,7 +6057,7 @@
                 <a:ea typeface="Calibri" pitchFamily="34" charset="-122"/>
                 <a:cs typeface="Calibri" pitchFamily="34" charset="-120"/>
               </a:rPr>
-              <a:t>afloat</a:t>
+              <a:t>awake</a:t>
             </a:r>
             <a:pPr algn="l" indent="0" marL="0">
               <a:buNone/>
@@ -6071,7 +6071,7 @@
                 <a:ea typeface="Calibri" pitchFamily="34" charset="-122"/>
                 <a:cs typeface="Calibri" pitchFamily="34" charset="-120"/>
               </a:rPr>
-              <a:t> after the storm, and they guided the boat </a:t>
+              <a:t> listening to the wind howling </a:t>
             </a:r>
             <a:pPr algn="l" indent="0" marL="0">
               <a:buNone/>
@@ -6088,7 +6088,7 @@
                 <a:ea typeface="Calibri" pitchFamily="34" charset="-122"/>
                 <a:cs typeface="Calibri" pitchFamily="34" charset="-120"/>
               </a:rPr>
-              <a:t>ashore</a:t>
+              <a:t>outside</a:t>
             </a:r>
             <a:pPr algn="l" indent="0" marL="0">
               <a:buNone/>
@@ -6102,7 +6102,7 @@
                 <a:ea typeface="Calibri" pitchFamily="34" charset="-122"/>
                 <a:cs typeface="Calibri" pitchFamily="34" charset="-120"/>
               </a:rPr>
-              <a:t> safely.</a:t>
+              <a:t>.</a:t>
             </a:r>
             <a:endParaRPr lang="en-US" sz="1800" dirty="0"/>
           </a:p>
@@ -6257,7 +6257,7 @@
                 <a:ea typeface="Trebuchet MS" pitchFamily="34" charset="-122"/>
                 <a:cs typeface="Trebuchet MS" pitchFamily="34" charset="-120"/>
               </a:rPr>
-              <a:t>afloat</a:t>
+              <a:t>awake</a:t>
             </a:r>
             <a:endParaRPr lang="en-US" sz="1400" dirty="0"/>
           </a:p>
@@ -6385,7 +6385,7 @@
                 <a:ea typeface="Trebuchet MS" pitchFamily="34" charset="-122"/>
                 <a:cs typeface="Trebuchet MS" pitchFamily="34" charset="-120"/>
               </a:rPr>
-              <a:t>ashore</a:t>
+              <a:t>outside</a:t>
             </a:r>
             <a:endParaRPr lang="en-US" sz="1400" dirty="0"/>
           </a:p>
@@ -6716,7 +6716,7 @@
                 <a:ea typeface="Calibri" pitchFamily="34" charset="-122"/>
                 <a:cs typeface="Calibri" pitchFamily="34" charset="-120"/>
               </a:rPr>
-              <a:t>Word Labs  •  wordlabs.app  •  Prefix: 'a-' = on, in, or into a state</a:t>
+              <a:t>Word Labs  •  wordlabs.app  •  Prefix: 'a-' = not, without, on, toward</a:t>
             </a:r>
             <a:endParaRPr lang="en-US" sz="800" dirty="0"/>
           </a:p>
@@ -6855,7 +6855,7 @@
                 <a:ea typeface="Trebuchet MS" pitchFamily="34" charset="-122"/>
                 <a:cs typeface="Trebuchet MS" pitchFamily="34" charset="-120"/>
               </a:rPr>
-              <a:t>afloat</a:t>
+              <a:t>awake</a:t>
             </a:r>
             <a:endParaRPr lang="en-US" sz="2800" dirty="0"/>
           </a:p>
@@ -7543,7 +7543,7 @@
                 <a:ea typeface="Calibri" pitchFamily="34" charset="-122"/>
                 <a:cs typeface="Calibri" pitchFamily="34" charset="-120"/>
               </a:rPr>
-              <a:t>Word Labs  •  wordlabs.app  •  Prefix: 'a-' = on, in, or into a state</a:t>
+              <a:t>Word Labs  •  wordlabs.app  •  Prefix: 'a-' = not, without, on, toward</a:t>
             </a:r>
             <a:endParaRPr lang="en-US" sz="800" dirty="0"/>
           </a:p>
@@ -7682,7 +7682,7 @@
                 <a:ea typeface="Trebuchet MS" pitchFamily="34" charset="-122"/>
                 <a:cs typeface="Trebuchet MS" pitchFamily="34" charset="-120"/>
               </a:rPr>
-              <a:t>afloat</a:t>
+              <a:t>awake</a:t>
             </a:r>
             <a:endParaRPr lang="en-US" sz="2800" dirty="0"/>
           </a:p>
@@ -7933,7 +7933,7 @@
                 <a:ea typeface="Trebuchet MS" pitchFamily="34" charset="-122"/>
                 <a:cs typeface="Trebuchet MS" pitchFamily="34" charset="-120"/>
               </a:rPr>
-              <a:t>float</a:t>
+              <a:t>wake</a:t>
             </a:r>
             <a:endParaRPr lang="en-US" sz="1300" dirty="0"/>
           </a:p>
@@ -7972,7 +7972,7 @@
                 <a:ea typeface="Calibri" pitchFamily="34" charset="-122"/>
                 <a:cs typeface="Calibri" pitchFamily="34" charset="-120"/>
               </a:rPr>
-              <a:t>rest on water</a:t>
+              <a:t>to rouse from sleep</a:t>
             </a:r>
             <a:endParaRPr lang="en-US" sz="850" dirty="0"/>
           </a:p>
@@ -8528,7 +8528,7 @@
                 <a:ea typeface="Calibri" pitchFamily="34" charset="-122"/>
                 <a:cs typeface="Calibri" pitchFamily="34" charset="-120"/>
               </a:rPr>
-              <a:t>Word Labs  •  wordlabs.app  •  Prefix: 'a-' = on, in, or into a state</a:t>
+              <a:t>Word Labs  •  wordlabs.app  •  Prefix: 'a-' = not, without, on, toward</a:t>
             </a:r>
             <a:endParaRPr lang="en-US" sz="800" dirty="0"/>
           </a:p>
@@ -8667,7 +8667,7 @@
                 <a:ea typeface="Trebuchet MS" pitchFamily="34" charset="-122"/>
                 <a:cs typeface="Trebuchet MS" pitchFamily="34" charset="-120"/>
               </a:rPr>
-              <a:t>afloat</a:t>
+              <a:t>awake</a:t>
             </a:r>
             <a:endParaRPr lang="en-US" sz="2800" dirty="0"/>
           </a:p>
@@ -8918,7 +8918,7 @@
                 <a:ea typeface="Trebuchet MS" pitchFamily="34" charset="-122"/>
                 <a:cs typeface="Trebuchet MS" pitchFamily="34" charset="-120"/>
               </a:rPr>
-              <a:t>float</a:t>
+              <a:t>wake</a:t>
             </a:r>
             <a:endParaRPr lang="en-US" sz="1300" dirty="0"/>
           </a:p>
@@ -8957,7 +8957,7 @@
                 <a:ea typeface="Calibri" pitchFamily="34" charset="-122"/>
                 <a:cs typeface="Calibri" pitchFamily="34" charset="-120"/>
               </a:rPr>
-              <a:t>rest on water</a:t>
+              <a:t>to rouse from sleep</a:t>
             </a:r>
             <a:endParaRPr lang="en-US" sz="850" dirty="0"/>
           </a:p>
@@ -9221,7 +9221,7 @@
                 <a:ea typeface="Trebuchet MS" pitchFamily="34" charset="-122"/>
                 <a:cs typeface="Trebuchet MS" pitchFamily="34" charset="-120"/>
               </a:rPr>
-              <a:t>float</a:t>
+              <a:t>wake</a:t>
             </a:r>
             <a:endParaRPr lang="en-US" sz="1400" dirty="0"/>
           </a:p>
@@ -9645,7 +9645,7 @@
                 <a:ea typeface="Calibri" pitchFamily="34" charset="-122"/>
                 <a:cs typeface="Calibri" pitchFamily="34" charset="-120"/>
               </a:rPr>
-              <a:t>Word Labs  •  wordlabs.app  •  Prefix: 'a-' = on, in, or into a state</a:t>
+              <a:t>Word Labs  •  wordlabs.app  •  Prefix: 'a-' = not, without, on, toward</a:t>
             </a:r>
             <a:endParaRPr lang="en-US" sz="800" dirty="0"/>
           </a:p>
@@ -9784,7 +9784,7 @@
                 <a:ea typeface="Trebuchet MS" pitchFamily="34" charset="-122"/>
                 <a:cs typeface="Trebuchet MS" pitchFamily="34" charset="-120"/>
               </a:rPr>
-              <a:t>afloat</a:t>
+              <a:t>awake</a:t>
             </a:r>
             <a:endParaRPr lang="en-US" sz="2800" dirty="0"/>
           </a:p>
@@ -10035,7 +10035,7 @@
                 <a:ea typeface="Trebuchet MS" pitchFamily="34" charset="-122"/>
                 <a:cs typeface="Trebuchet MS" pitchFamily="34" charset="-120"/>
               </a:rPr>
-              <a:t>float</a:t>
+              <a:t>wake</a:t>
             </a:r>
             <a:endParaRPr lang="en-US" sz="1300" dirty="0"/>
           </a:p>
@@ -10074,7 +10074,7 @@
                 <a:ea typeface="Calibri" pitchFamily="34" charset="-122"/>
                 <a:cs typeface="Calibri" pitchFamily="34" charset="-120"/>
               </a:rPr>
-              <a:t>rest on water</a:t>
+              <a:t>to rouse from sleep</a:t>
             </a:r>
             <a:endParaRPr lang="en-US" sz="850" dirty="0"/>
           </a:p>
@@ -10338,7 +10338,7 @@
                 <a:ea typeface="Trebuchet MS" pitchFamily="34" charset="-122"/>
                 <a:cs typeface="Trebuchet MS" pitchFamily="34" charset="-120"/>
               </a:rPr>
-              <a:t>float</a:t>
+              <a:t>wake</a:t>
             </a:r>
             <a:endParaRPr lang="en-US" sz="1400" dirty="0"/>
           </a:p>
@@ -10419,11 +10419,11 @@
         <p:spPr>
           <a:xfrm>
             <a:off x="1874520" y="4096512"/>
-            <a:ext cx="6903720" cy="658368"/>
+            <a:ext cx="6903720" cy="804672"/>
           </a:xfrm>
           <a:prstGeom prst="rect">
             <a:avLst>
-              <a:gd name="adj" fmla="val 8333"/>
+              <a:gd name="adj" fmla="val 6818"/>
             </a:avLst>
           </a:prstGeom>
           <a:solidFill>
@@ -10445,12 +10445,12 @@
         </p:nvSpPr>
         <p:spPr>
           <a:xfrm>
-            <a:off x="2427732" y="4169664"/>
-            <a:ext cx="685800" cy="475488"/>
+            <a:off x="2670048" y="4169664"/>
+            <a:ext cx="685800" cy="384048"/>
           </a:xfrm>
           <a:prstGeom prst="rect">
             <a:avLst>
-              <a:gd name="adj" fmla="val 7692"/>
+              <a:gd name="adj" fmla="val 9524"/>
             </a:avLst>
           </a:prstGeom>
           <a:solidFill>
@@ -10472,8 +10472,8 @@
         </p:nvSpPr>
         <p:spPr>
           <a:xfrm>
-            <a:off x="2427732" y="4169664"/>
-            <a:ext cx="685800" cy="475488"/>
+            <a:off x="2670048" y="4169664"/>
+            <a:ext cx="685800" cy="384048"/>
           </a:xfrm>
           <a:prstGeom prst="rect">
             <a:avLst/>
@@ -10511,12 +10511,12 @@
         </p:nvSpPr>
         <p:spPr>
           <a:xfrm>
-            <a:off x="3639312" y="4169664"/>
-            <a:ext cx="685800" cy="475488"/>
+            <a:off x="4123944" y="4169664"/>
+            <a:ext cx="685800" cy="384048"/>
           </a:xfrm>
           <a:prstGeom prst="rect">
             <a:avLst>
-              <a:gd name="adj" fmla="val 7692"/>
+              <a:gd name="adj" fmla="val 9524"/>
             </a:avLst>
           </a:prstGeom>
           <a:solidFill>
@@ -10538,8 +10538,8 @@
         </p:nvSpPr>
         <p:spPr>
           <a:xfrm>
-            <a:off x="3639312" y="4169664"/>
-            <a:ext cx="685800" cy="475488"/>
+            <a:off x="4123944" y="4169664"/>
+            <a:ext cx="685800" cy="384048"/>
           </a:xfrm>
           <a:prstGeom prst="rect">
             <a:avLst/>
@@ -10563,7 +10563,7 @@
                 <a:ea typeface="Trebuchet MS" pitchFamily="34" charset="-122"/>
                 <a:cs typeface="Trebuchet MS" pitchFamily="34" charset="-120"/>
               </a:rPr>
-              <a:t>f</a:t>
+              <a:t>w</a:t>
             </a:r>
             <a:endParaRPr lang="en-US" sz="900" dirty="0"/>
           </a:p>
@@ -10577,12 +10577,12 @@
         </p:nvSpPr>
         <p:spPr>
           <a:xfrm>
-            <a:off x="4850892" y="4169664"/>
-            <a:ext cx="685800" cy="475488"/>
+            <a:off x="5577840" y="4169664"/>
+            <a:ext cx="685800" cy="384048"/>
           </a:xfrm>
           <a:prstGeom prst="rect">
             <a:avLst>
-              <a:gd name="adj" fmla="val 7692"/>
+              <a:gd name="adj" fmla="val 9524"/>
             </a:avLst>
           </a:prstGeom>
           <a:solidFill>
@@ -10604,8 +10604,8 @@
         </p:nvSpPr>
         <p:spPr>
           <a:xfrm>
-            <a:off x="4850892" y="4169664"/>
-            <a:ext cx="685800" cy="475488"/>
+            <a:off x="5577840" y="4169664"/>
+            <a:ext cx="685800" cy="384048"/>
           </a:xfrm>
           <a:prstGeom prst="rect">
             <a:avLst/>
@@ -10629,7 +10629,7 @@
                 <a:ea typeface="Trebuchet MS" pitchFamily="34" charset="-122"/>
                 <a:cs typeface="Trebuchet MS" pitchFamily="34" charset="-120"/>
               </a:rPr>
-              <a:t>l</a:t>
+              <a:t>a</a:t>
             </a:r>
             <a:endParaRPr lang="en-US" sz="900" dirty="0"/>
           </a:p>
@@ -10643,12 +10643,12 @@
         </p:nvSpPr>
         <p:spPr>
           <a:xfrm>
-            <a:off x="6062472" y="4169664"/>
-            <a:ext cx="685800" cy="475488"/>
+            <a:off x="7031736" y="4169664"/>
+            <a:ext cx="685800" cy="384048"/>
           </a:xfrm>
           <a:prstGeom prst="rect">
             <a:avLst>
-              <a:gd name="adj" fmla="val 7692"/>
+              <a:gd name="adj" fmla="val 9524"/>
             </a:avLst>
           </a:prstGeom>
           <a:solidFill>
@@ -10670,8 +10670,8 @@
         </p:nvSpPr>
         <p:spPr>
           <a:xfrm>
-            <a:off x="6062472" y="4169664"/>
-            <a:ext cx="685800" cy="475488"/>
+            <a:off x="7031736" y="4169664"/>
+            <a:ext cx="685800" cy="384048"/>
           </a:xfrm>
           <a:prstGeom prst="rect">
             <a:avLst/>
@@ -10695,7 +10695,7 @@
                 <a:ea typeface="Trebuchet MS" pitchFamily="34" charset="-122"/>
                 <a:cs typeface="Trebuchet MS" pitchFamily="34" charset="-120"/>
               </a:rPr>
-              <a:t>oa</a:t>
+              <a:t>ke</a:t>
             </a:r>
             <a:endParaRPr lang="en-US" sz="900" dirty="0"/>
           </a:p>
@@ -10703,67 +10703,40 @@
       </p:sp>
       <p:sp>
         <p:nvSpPr>
-          <p:cNvPr id="41" name="Shape 39"/>
-          <p:cNvSpPr/>
-          <p:nvPr/>
-        </p:nvSpPr>
-        <p:spPr>
-          <a:xfrm>
-            <a:off x="7274052" y="4169664"/>
-            <a:ext cx="685800" cy="475488"/>
-          </a:xfrm>
-          <a:prstGeom prst="rect">
-            <a:avLst>
-              <a:gd name="adj" fmla="val 7692"/>
-            </a:avLst>
-          </a:prstGeom>
-          <a:solidFill>
-            <a:srgbClr val="FFFFFF"/>
-          </a:solidFill>
-          <a:ln w="12700">
-            <a:solidFill>
-              <a:srgbClr val="DB2777"/>
-            </a:solidFill>
-            <a:prstDash val="solid"/>
-          </a:ln>
-        </p:spPr>
-      </p:sp>
-      <p:sp>
-        <p:nvSpPr>
-          <p:cNvPr id="42" name="Text 40"/>
-          <p:cNvSpPr/>
-          <p:nvPr/>
-        </p:nvSpPr>
-        <p:spPr>
-          <a:xfrm>
-            <a:off x="7274052" y="4169664"/>
-            <a:ext cx="685800" cy="475488"/>
-          </a:xfrm>
-          <a:prstGeom prst="rect">
-            <a:avLst/>
-          </a:prstGeom>
-          <a:noFill/>
-          <a:ln/>
-        </p:spPr>
-        <p:txBody>
-          <a:bodyPr wrap="square" lIns="0" tIns="0" rIns="0" bIns="0" rtlCol="0" anchor="ctr"/>
-          <a:lstStyle/>
-          <a:p>
-            <a:pPr algn="ctr" indent="0" marL="0">
-              <a:buNone/>
-            </a:pPr>
-            <a:r>
-              <a:rPr lang="en-US" sz="900" b="1" dirty="0">
-                <a:solidFill>
-                  <a:srgbClr val="9D174D"/>
-                </a:solidFill>
-                <a:latin typeface="Trebuchet MS" pitchFamily="34" charset="0"/>
-                <a:ea typeface="Trebuchet MS" pitchFamily="34" charset="-122"/>
-                <a:cs typeface="Trebuchet MS" pitchFamily="34" charset="-120"/>
-              </a:rPr>
-              <a:t>t</a:t>
-            </a:r>
-            <a:endParaRPr lang="en-US" sz="900" dirty="0"/>
+          <p:cNvPr id="41" name="Text 39"/>
+          <p:cNvSpPr/>
+          <p:nvPr/>
+        </p:nvSpPr>
+        <p:spPr>
+          <a:xfrm>
+            <a:off x="7031736" y="4572000"/>
+            <a:ext cx="685800" cy="219456"/>
+          </a:xfrm>
+          <a:prstGeom prst="rect">
+            <a:avLst/>
+          </a:prstGeom>
+          <a:noFill/>
+          <a:ln/>
+        </p:spPr>
+        <p:txBody>
+          <a:bodyPr wrap="square" lIns="0" tIns="0" rIns="0" bIns="0" rtlCol="0" anchor="t"/>
+          <a:lstStyle/>
+          <a:p>
+            <a:pPr algn="ctr" indent="0" marL="0">
+              <a:buNone/>
+            </a:pPr>
+            <a:r>
+              <a:rPr lang="en-US" sz="750" i="1" dirty="0">
+                <a:solidFill>
+                  <a:srgbClr val="94A3B8"/>
+                </a:solidFill>
+                <a:latin typeface="Calibri" pitchFamily="34" charset="0"/>
+                <a:ea typeface="Calibri" pitchFamily="34" charset="-122"/>
+                <a:cs typeface="Calibri" pitchFamily="34" charset="-120"/>
+              </a:rPr>
+              <a:t>/k/</a:t>
+            </a:r>
+            <a:endParaRPr lang="en-US" sz="750" dirty="0"/>
           </a:p>
         </p:txBody>
       </p:sp>
@@ -11053,7 +11026,7 @@
                 <a:ea typeface="Calibri" pitchFamily="34" charset="-122"/>
                 <a:cs typeface="Calibri" pitchFamily="34" charset="-120"/>
               </a:rPr>
-              <a:t>Word Labs  •  wordlabs.app  •  Prefix: 'a-' = on, in, or into a state</a:t>
+              <a:t>Word Labs  •  wordlabs.app  •  Prefix: 'a-' = not, without, on, toward</a:t>
             </a:r>
             <a:endParaRPr lang="en-US" sz="800" dirty="0"/>
           </a:p>
@@ -11192,7 +11165,7 @@
                 <a:ea typeface="Trebuchet MS" pitchFamily="34" charset="-122"/>
                 <a:cs typeface="Trebuchet MS" pitchFamily="34" charset="-120"/>
               </a:rPr>
-              <a:t>ashore</a:t>
+              <a:t>outside</a:t>
             </a:r>
             <a:endParaRPr lang="en-US" sz="2800" dirty="0"/>
           </a:p>
@@ -11880,7 +11853,7 @@
                 <a:ea typeface="Calibri" pitchFamily="34" charset="-122"/>
                 <a:cs typeface="Calibri" pitchFamily="34" charset="-120"/>
               </a:rPr>
-              <a:t>Word Labs  •  wordlabs.app  •  Prefix: 'a-' = on, in, or into a state</a:t>
+              <a:t>Word Labs  •  wordlabs.app  •  Prefix: 'a-' = not, without, on, toward</a:t>
             </a:r>
             <a:endParaRPr lang="en-US" sz="800" dirty="0"/>
           </a:p>
@@ -12019,7 +11992,7 @@
                 <a:ea typeface="Trebuchet MS" pitchFamily="34" charset="-122"/>
                 <a:cs typeface="Trebuchet MS" pitchFamily="34" charset="-120"/>
               </a:rPr>
-              <a:t>ashore</a:t>
+              <a:t>outside</a:t>
             </a:r>
             <a:endParaRPr lang="en-US" sz="2800" dirty="0"/>
           </a:p>
@@ -12108,11 +12081,11 @@
             </a:avLst>
           </a:prstGeom>
           <a:solidFill>
-            <a:srgbClr val="CCFBF1"/>
+            <a:srgbClr val="DDD6FE"/>
           </a:solidFill>
           <a:ln w="19050">
             <a:solidFill>
-              <a:srgbClr val="0D9488"/>
+              <a:srgbClr val="7C3AED"/>
             </a:solidFill>
             <a:prstDash val="solid"/>
           </a:ln>
@@ -12152,13 +12125,13 @@
             <a:r>
               <a:rPr lang="en-US" sz="1300" b="1" dirty="0">
                 <a:solidFill>
-                  <a:srgbClr val="0F766E"/>
+                  <a:srgbClr val="4C1D95"/>
                 </a:solidFill>
                 <a:latin typeface="Trebuchet MS" pitchFamily="34" charset="0"/>
                 <a:ea typeface="Trebuchet MS" pitchFamily="34" charset="-122"/>
                 <a:cs typeface="Trebuchet MS" pitchFamily="34" charset="-120"/>
               </a:rPr>
-              <a:t>a</a:t>
+              <a:t>out</a:t>
             </a:r>
             <a:endParaRPr lang="en-US" sz="1300" dirty="0"/>
           </a:p>
@@ -12197,7 +12170,7 @@
                 <a:ea typeface="Calibri" pitchFamily="34" charset="-122"/>
                 <a:cs typeface="Calibri" pitchFamily="34" charset="-120"/>
               </a:rPr>
-              <a:t>on or towards</a:t>
+              <a:t>beyond</a:t>
             </a:r>
             <a:endParaRPr lang="en-US" sz="850" dirty="0"/>
           </a:p>
@@ -12270,7 +12243,7 @@
                 <a:ea typeface="Trebuchet MS" pitchFamily="34" charset="-122"/>
                 <a:cs typeface="Trebuchet MS" pitchFamily="34" charset="-120"/>
               </a:rPr>
-              <a:t>shore</a:t>
+              <a:t>side</a:t>
             </a:r>
             <a:endParaRPr lang="en-US" sz="1300" dirty="0"/>
           </a:p>
@@ -12309,7 +12282,7 @@
                 <a:ea typeface="Calibri" pitchFamily="34" charset="-122"/>
                 <a:cs typeface="Calibri" pitchFamily="34" charset="-120"/>
               </a:rPr>
-              <a:t>edge of land by water</a:t>
+              <a:t>edge or surface</a:t>
             </a:r>
             <a:endParaRPr lang="en-US" sz="850" dirty="0"/>
           </a:p>
@@ -12865,7 +12838,7 @@
                 <a:ea typeface="Calibri" pitchFamily="34" charset="-122"/>
                 <a:cs typeface="Calibri" pitchFamily="34" charset="-120"/>
               </a:rPr>
-              <a:t>Word Labs  •  wordlabs.app  •  Prefix: 'a-' = on, in, or into a state</a:t>
+              <a:t>Word Labs  •  wordlabs.app  •  Prefix: 'a-' = not, without, on, toward</a:t>
             </a:r>
             <a:endParaRPr lang="en-US" sz="800" dirty="0"/>
           </a:p>
@@ -13004,7 +12977,7 @@
                 <a:ea typeface="Trebuchet MS" pitchFamily="34" charset="-122"/>
                 <a:cs typeface="Trebuchet MS" pitchFamily="34" charset="-120"/>
               </a:rPr>
-              <a:t>ashore</a:t>
+              <a:t>outside</a:t>
             </a:r>
             <a:endParaRPr lang="en-US" sz="2800" dirty="0"/>
           </a:p>
@@ -13093,11 +13066,11 @@
             </a:avLst>
           </a:prstGeom>
           <a:solidFill>
-            <a:srgbClr val="CCFBF1"/>
+            <a:srgbClr val="DDD6FE"/>
           </a:solidFill>
           <a:ln w="19050">
             <a:solidFill>
-              <a:srgbClr val="0D9488"/>
+              <a:srgbClr val="7C3AED"/>
             </a:solidFill>
             <a:prstDash val="solid"/>
           </a:ln>
@@ -13137,13 +13110,13 @@
             <a:r>
               <a:rPr lang="en-US" sz="1300" b="1" dirty="0">
                 <a:solidFill>
-                  <a:srgbClr val="0F766E"/>
+                  <a:srgbClr val="4C1D95"/>
                 </a:solidFill>
                 <a:latin typeface="Trebuchet MS" pitchFamily="34" charset="0"/>
                 <a:ea typeface="Trebuchet MS" pitchFamily="34" charset="-122"/>
                 <a:cs typeface="Trebuchet MS" pitchFamily="34" charset="-120"/>
               </a:rPr>
-              <a:t>a</a:t>
+              <a:t>out</a:t>
             </a:r>
             <a:endParaRPr lang="en-US" sz="1300" dirty="0"/>
           </a:p>
@@ -13182,7 +13155,7 @@
                 <a:ea typeface="Calibri" pitchFamily="34" charset="-122"/>
                 <a:cs typeface="Calibri" pitchFamily="34" charset="-120"/>
               </a:rPr>
-              <a:t>on or towards</a:t>
+              <a:t>beyond</a:t>
             </a:r>
             <a:endParaRPr lang="en-US" sz="850" dirty="0"/>
           </a:p>
@@ -13255,7 +13228,7 @@
                 <a:ea typeface="Trebuchet MS" pitchFamily="34" charset="-122"/>
                 <a:cs typeface="Trebuchet MS" pitchFamily="34" charset="-120"/>
               </a:rPr>
-              <a:t>shore</a:t>
+              <a:t>side</a:t>
             </a:r>
             <a:endParaRPr lang="en-US" sz="1300" dirty="0"/>
           </a:p>
@@ -13294,7 +13267,7 @@
                 <a:ea typeface="Calibri" pitchFamily="34" charset="-122"/>
                 <a:cs typeface="Calibri" pitchFamily="34" charset="-120"/>
               </a:rPr>
-              <a:t>edge of land by water</a:t>
+              <a:t>edge or surface</a:t>
             </a:r>
             <a:endParaRPr lang="en-US" sz="850" dirty="0"/>
           </a:p>
@@ -13453,7 +13426,7 @@
                 <a:ea typeface="Trebuchet MS" pitchFamily="34" charset="-122"/>
                 <a:cs typeface="Trebuchet MS" pitchFamily="34" charset="-120"/>
               </a:rPr>
-              <a:t>a</a:t>
+              <a:t>out</a:t>
             </a:r>
             <a:endParaRPr lang="en-US" sz="1400" dirty="0"/>
           </a:p>
@@ -13558,7 +13531,7 @@
                 <a:ea typeface="Trebuchet MS" pitchFamily="34" charset="-122"/>
                 <a:cs typeface="Trebuchet MS" pitchFamily="34" charset="-120"/>
               </a:rPr>
-              <a:t>shore</a:t>
+              <a:t>side</a:t>
             </a:r>
             <a:endParaRPr lang="en-US" sz="1400" dirty="0"/>
           </a:p>
@@ -13891,7 +13864,7 @@
                 <a:ea typeface="Calibri" pitchFamily="34" charset="-122"/>
                 <a:cs typeface="Calibri" pitchFamily="34" charset="-120"/>
               </a:rPr>
-              <a:t>Prefix 'a-' — on, in, or into a state</a:t>
+              <a:t>Prefix 'a-' — not, without, on, toward</a:t>
             </a:r>
             <a:endParaRPr lang="en-US" sz="1600" dirty="0"/>
           </a:p>
@@ -14247,7 +14220,7 @@
                 <a:ea typeface="Calibri" pitchFamily="34" charset="-122"/>
                 <a:cs typeface="Calibri" pitchFamily="34" charset="-120"/>
               </a:rPr>
-              <a:t>Word Labs  •  wordlabs.app  •  Prefix: 'a-' = on, in, or into a state</a:t>
+              <a:t>Word Labs  •  wordlabs.app  •  Prefix: 'a-' = not, without, on, toward</a:t>
             </a:r>
             <a:endParaRPr lang="en-US" sz="800" dirty="0"/>
           </a:p>
@@ -14386,7 +14359,7 @@
                 <a:ea typeface="Trebuchet MS" pitchFamily="34" charset="-122"/>
                 <a:cs typeface="Trebuchet MS" pitchFamily="34" charset="-120"/>
               </a:rPr>
-              <a:t>ashore</a:t>
+              <a:t>outside</a:t>
             </a:r>
             <a:endParaRPr lang="en-US" sz="2800" dirty="0"/>
           </a:p>
@@ -14475,11 +14448,11 @@
             </a:avLst>
           </a:prstGeom>
           <a:solidFill>
-            <a:srgbClr val="CCFBF1"/>
+            <a:srgbClr val="DDD6FE"/>
           </a:solidFill>
           <a:ln w="19050">
             <a:solidFill>
-              <a:srgbClr val="0D9488"/>
+              <a:srgbClr val="7C3AED"/>
             </a:solidFill>
             <a:prstDash val="solid"/>
           </a:ln>
@@ -14519,13 +14492,13 @@
             <a:r>
               <a:rPr lang="en-US" sz="1300" b="1" dirty="0">
                 <a:solidFill>
-                  <a:srgbClr val="0F766E"/>
+                  <a:srgbClr val="4C1D95"/>
                 </a:solidFill>
                 <a:latin typeface="Trebuchet MS" pitchFamily="34" charset="0"/>
                 <a:ea typeface="Trebuchet MS" pitchFamily="34" charset="-122"/>
                 <a:cs typeface="Trebuchet MS" pitchFamily="34" charset="-120"/>
               </a:rPr>
-              <a:t>a</a:t>
+              <a:t>out</a:t>
             </a:r>
             <a:endParaRPr lang="en-US" sz="1300" dirty="0"/>
           </a:p>
@@ -14564,7 +14537,7 @@
                 <a:ea typeface="Calibri" pitchFamily="34" charset="-122"/>
                 <a:cs typeface="Calibri" pitchFamily="34" charset="-120"/>
               </a:rPr>
-              <a:t>on or towards</a:t>
+              <a:t>beyond</a:t>
             </a:r>
             <a:endParaRPr lang="en-US" sz="850" dirty="0"/>
           </a:p>
@@ -14637,7 +14610,7 @@
                 <a:ea typeface="Trebuchet MS" pitchFamily="34" charset="-122"/>
                 <a:cs typeface="Trebuchet MS" pitchFamily="34" charset="-120"/>
               </a:rPr>
-              <a:t>shore</a:t>
+              <a:t>side</a:t>
             </a:r>
             <a:endParaRPr lang="en-US" sz="1300" dirty="0"/>
           </a:p>
@@ -14676,7 +14649,7 @@
                 <a:ea typeface="Calibri" pitchFamily="34" charset="-122"/>
                 <a:cs typeface="Calibri" pitchFamily="34" charset="-120"/>
               </a:rPr>
-              <a:t>edge of land by water</a:t>
+              <a:t>edge or surface</a:t>
             </a:r>
             <a:endParaRPr lang="en-US" sz="850" dirty="0"/>
           </a:p>
@@ -14835,7 +14808,7 @@
                 <a:ea typeface="Trebuchet MS" pitchFamily="34" charset="-122"/>
                 <a:cs typeface="Trebuchet MS" pitchFamily="34" charset="-120"/>
               </a:rPr>
-              <a:t>a</a:t>
+              <a:t>out</a:t>
             </a:r>
             <a:endParaRPr lang="en-US" sz="1400" dirty="0"/>
           </a:p>
@@ -14940,7 +14913,7 @@
                 <a:ea typeface="Trebuchet MS" pitchFamily="34" charset="-122"/>
                 <a:cs typeface="Trebuchet MS" pitchFamily="34" charset="-120"/>
               </a:rPr>
-              <a:t>shore</a:t>
+              <a:t>side</a:t>
             </a:r>
             <a:endParaRPr lang="en-US" sz="1400" dirty="0"/>
           </a:p>
@@ -15021,11 +14994,11 @@
         <p:spPr>
           <a:xfrm>
             <a:off x="1874520" y="4096512"/>
-            <a:ext cx="6903720" cy="804672"/>
+            <a:ext cx="6903720" cy="658368"/>
           </a:xfrm>
           <a:prstGeom prst="rect">
             <a:avLst>
-              <a:gd name="adj" fmla="val 6818"/>
+              <a:gd name="adj" fmla="val 8333"/>
             </a:avLst>
           </a:prstGeom>
           <a:solidFill>
@@ -15047,12 +15020,12 @@
         </p:nvSpPr>
         <p:spPr>
           <a:xfrm>
-            <a:off x="2670048" y="4169664"/>
-            <a:ext cx="685800" cy="384048"/>
+            <a:off x="2254649" y="4169664"/>
+            <a:ext cx="685800" cy="475488"/>
           </a:xfrm>
           <a:prstGeom prst="rect">
             <a:avLst>
-              <a:gd name="adj" fmla="val 9524"/>
+              <a:gd name="adj" fmla="val 7692"/>
             </a:avLst>
           </a:prstGeom>
           <a:solidFill>
@@ -15074,8 +15047,8 @@
         </p:nvSpPr>
         <p:spPr>
           <a:xfrm>
-            <a:off x="2670048" y="4169664"/>
-            <a:ext cx="685800" cy="384048"/>
+            <a:off x="2254649" y="4169664"/>
+            <a:ext cx="685800" cy="475488"/>
           </a:xfrm>
           <a:prstGeom prst="rect">
             <a:avLst/>
@@ -15099,7 +15072,7 @@
                 <a:ea typeface="Trebuchet MS" pitchFamily="34" charset="-122"/>
                 <a:cs typeface="Trebuchet MS" pitchFamily="34" charset="-120"/>
               </a:rPr>
-              <a:t>a</a:t>
+              <a:t>ou</a:t>
             </a:r>
             <a:endParaRPr lang="en-US" sz="900" dirty="0"/>
           </a:p>
@@ -15113,12 +15086,12 @@
         </p:nvSpPr>
         <p:spPr>
           <a:xfrm>
-            <a:off x="4123944" y="4169664"/>
-            <a:ext cx="685800" cy="384048"/>
+            <a:off x="3293146" y="4169664"/>
+            <a:ext cx="685800" cy="475488"/>
           </a:xfrm>
           <a:prstGeom prst="rect">
             <a:avLst>
-              <a:gd name="adj" fmla="val 9524"/>
+              <a:gd name="adj" fmla="val 7692"/>
             </a:avLst>
           </a:prstGeom>
           <a:solidFill>
@@ -15140,8 +15113,8 @@
         </p:nvSpPr>
         <p:spPr>
           <a:xfrm>
-            <a:off x="4123944" y="4169664"/>
-            <a:ext cx="685800" cy="384048"/>
+            <a:off x="3293146" y="4169664"/>
+            <a:ext cx="685800" cy="475488"/>
           </a:xfrm>
           <a:prstGeom prst="rect">
             <a:avLst/>
@@ -15165,7 +15138,7 @@
                 <a:ea typeface="Trebuchet MS" pitchFamily="34" charset="-122"/>
                 <a:cs typeface="Trebuchet MS" pitchFamily="34" charset="-120"/>
               </a:rPr>
-              <a:t>sh</a:t>
+              <a:t>t</a:t>
             </a:r>
             <a:endParaRPr lang="en-US" sz="900" dirty="0"/>
           </a:p>
@@ -15179,12 +15152,12 @@
         </p:nvSpPr>
         <p:spPr>
           <a:xfrm>
-            <a:off x="5577840" y="4169664"/>
-            <a:ext cx="685800" cy="384048"/>
+            <a:off x="4331643" y="4169664"/>
+            <a:ext cx="685800" cy="475488"/>
           </a:xfrm>
           <a:prstGeom prst="rect">
             <a:avLst>
-              <a:gd name="adj" fmla="val 9524"/>
+              <a:gd name="adj" fmla="val 7692"/>
             </a:avLst>
           </a:prstGeom>
           <a:solidFill>
@@ -15206,8 +15179,8 @@
         </p:nvSpPr>
         <p:spPr>
           <a:xfrm>
-            <a:off x="5577840" y="4169664"/>
-            <a:ext cx="685800" cy="384048"/>
+            <a:off x="4331643" y="4169664"/>
+            <a:ext cx="685800" cy="475488"/>
           </a:xfrm>
           <a:prstGeom prst="rect">
             <a:avLst/>
@@ -15231,7 +15204,7 @@
                 <a:ea typeface="Trebuchet MS" pitchFamily="34" charset="-122"/>
                 <a:cs typeface="Trebuchet MS" pitchFamily="34" charset="-120"/>
               </a:rPr>
-              <a:t>or</a:t>
+              <a:t>s</a:t>
             </a:r>
             <a:endParaRPr lang="en-US" sz="900" dirty="0"/>
           </a:p>
@@ -15245,12 +15218,12 @@
         </p:nvSpPr>
         <p:spPr>
           <a:xfrm>
-            <a:off x="7031736" y="4169664"/>
-            <a:ext cx="685800" cy="384048"/>
+            <a:off x="5370141" y="4169664"/>
+            <a:ext cx="685800" cy="475488"/>
           </a:xfrm>
           <a:prstGeom prst="rect">
             <a:avLst>
-              <a:gd name="adj" fmla="val 9524"/>
+              <a:gd name="adj" fmla="val 7692"/>
             </a:avLst>
           </a:prstGeom>
           <a:solidFill>
@@ -15272,8 +15245,8 @@
         </p:nvSpPr>
         <p:spPr>
           <a:xfrm>
-            <a:off x="7031736" y="4169664"/>
-            <a:ext cx="685800" cy="384048"/>
+            <a:off x="5370141" y="4169664"/>
+            <a:ext cx="685800" cy="475488"/>
           </a:xfrm>
           <a:prstGeom prst="rect">
             <a:avLst/>
@@ -15297,48 +15270,141 @@
                 <a:ea typeface="Trebuchet MS" pitchFamily="34" charset="-122"/>
                 <a:cs typeface="Trebuchet MS" pitchFamily="34" charset="-120"/>
               </a:rPr>
+              <a:t>i</a:t>
+            </a:r>
+            <a:endParaRPr lang="en-US" sz="900" dirty="0"/>
+          </a:p>
+        </p:txBody>
+      </p:sp>
+      <p:sp>
+        <p:nvSpPr>
+          <p:cNvPr id="41" name="Shape 39"/>
+          <p:cNvSpPr/>
+          <p:nvPr/>
+        </p:nvSpPr>
+        <p:spPr>
+          <a:xfrm>
+            <a:off x="6408638" y="4169664"/>
+            <a:ext cx="685800" cy="475488"/>
+          </a:xfrm>
+          <a:prstGeom prst="rect">
+            <a:avLst>
+              <a:gd name="adj" fmla="val 7692"/>
+            </a:avLst>
+          </a:prstGeom>
+          <a:solidFill>
+            <a:srgbClr val="FFFFFF"/>
+          </a:solidFill>
+          <a:ln w="12700">
+            <a:solidFill>
+              <a:srgbClr val="DB2777"/>
+            </a:solidFill>
+            <a:prstDash val="solid"/>
+          </a:ln>
+        </p:spPr>
+      </p:sp>
+      <p:sp>
+        <p:nvSpPr>
+          <p:cNvPr id="42" name="Text 40"/>
+          <p:cNvSpPr/>
+          <p:nvPr/>
+        </p:nvSpPr>
+        <p:spPr>
+          <a:xfrm>
+            <a:off x="6408638" y="4169664"/>
+            <a:ext cx="685800" cy="475488"/>
+          </a:xfrm>
+          <a:prstGeom prst="rect">
+            <a:avLst/>
+          </a:prstGeom>
+          <a:noFill/>
+          <a:ln/>
+        </p:spPr>
+        <p:txBody>
+          <a:bodyPr wrap="square" lIns="0" tIns="0" rIns="0" bIns="0" rtlCol="0" anchor="ctr"/>
+          <a:lstStyle/>
+          <a:p>
+            <a:pPr algn="ctr" indent="0" marL="0">
+              <a:buNone/>
+            </a:pPr>
+            <a:r>
+              <a:rPr lang="en-US" sz="900" b="1" dirty="0">
+                <a:solidFill>
+                  <a:srgbClr val="9D174D"/>
+                </a:solidFill>
+                <a:latin typeface="Trebuchet MS" pitchFamily="34" charset="0"/>
+                <a:ea typeface="Trebuchet MS" pitchFamily="34" charset="-122"/>
+                <a:cs typeface="Trebuchet MS" pitchFamily="34" charset="-120"/>
+              </a:rPr>
+              <a:t>d</a:t>
+            </a:r>
+            <a:endParaRPr lang="en-US" sz="900" dirty="0"/>
+          </a:p>
+        </p:txBody>
+      </p:sp>
+      <p:sp>
+        <p:nvSpPr>
+          <p:cNvPr id="43" name="Shape 41"/>
+          <p:cNvSpPr/>
+          <p:nvPr/>
+        </p:nvSpPr>
+        <p:spPr>
+          <a:xfrm>
+            <a:off x="7447135" y="4169664"/>
+            <a:ext cx="685800" cy="475488"/>
+          </a:xfrm>
+          <a:prstGeom prst="rect">
+            <a:avLst>
+              <a:gd name="adj" fmla="val 7692"/>
+            </a:avLst>
+          </a:prstGeom>
+          <a:solidFill>
+            <a:srgbClr val="FFFFFF"/>
+          </a:solidFill>
+          <a:ln w="12700">
+            <a:solidFill>
+              <a:srgbClr val="DB2777"/>
+            </a:solidFill>
+            <a:prstDash val="solid"/>
+          </a:ln>
+        </p:spPr>
+      </p:sp>
+      <p:sp>
+        <p:nvSpPr>
+          <p:cNvPr id="44" name="Text 42"/>
+          <p:cNvSpPr/>
+          <p:nvPr/>
+        </p:nvSpPr>
+        <p:spPr>
+          <a:xfrm>
+            <a:off x="7447135" y="4169664"/>
+            <a:ext cx="685800" cy="475488"/>
+          </a:xfrm>
+          <a:prstGeom prst="rect">
+            <a:avLst/>
+          </a:prstGeom>
+          <a:noFill/>
+          <a:ln/>
+        </p:spPr>
+        <p:txBody>
+          <a:bodyPr wrap="square" lIns="0" tIns="0" rIns="0" bIns="0" rtlCol="0" anchor="ctr"/>
+          <a:lstStyle/>
+          <a:p>
+            <a:pPr algn="ctr" indent="0" marL="0">
+              <a:buNone/>
+            </a:pPr>
+            <a:r>
+              <a:rPr lang="en-US" sz="900" b="1" dirty="0">
+                <a:solidFill>
+                  <a:srgbClr val="9D174D"/>
+                </a:solidFill>
+                <a:latin typeface="Trebuchet MS" pitchFamily="34" charset="0"/>
+                <a:ea typeface="Trebuchet MS" pitchFamily="34" charset="-122"/>
+                <a:cs typeface="Trebuchet MS" pitchFamily="34" charset="-120"/>
+              </a:rPr>
               <a:t>e</a:t>
             </a:r>
             <a:endParaRPr lang="en-US" sz="900" dirty="0"/>
-          </a:p>
-        </p:txBody>
-      </p:sp>
-      <p:sp>
-        <p:nvSpPr>
-          <p:cNvPr id="41" name="Text 39"/>
-          <p:cNvSpPr/>
-          <p:nvPr/>
-        </p:nvSpPr>
-        <p:spPr>
-          <a:xfrm>
-            <a:off x="7031736" y="4572000"/>
-            <a:ext cx="685800" cy="219456"/>
-          </a:xfrm>
-          <a:prstGeom prst="rect">
-            <a:avLst/>
-          </a:prstGeom>
-          <a:noFill/>
-          <a:ln/>
-        </p:spPr>
-        <p:txBody>
-          <a:bodyPr wrap="square" lIns="0" tIns="0" rIns="0" bIns="0" rtlCol="0" anchor="t"/>
-          <a:lstStyle/>
-          <a:p>
-            <a:pPr algn="ctr" indent="0" marL="0">
-              <a:buNone/>
-            </a:pPr>
-            <a:r>
-              <a:rPr lang="en-US" sz="750" i="1" dirty="0">
-                <a:solidFill>
-                  <a:srgbClr val="94A3B8"/>
-                </a:solidFill>
-                <a:latin typeface="Calibri" pitchFamily="34" charset="0"/>
-                <a:ea typeface="Calibri" pitchFamily="34" charset="-122"/>
-                <a:cs typeface="Calibri" pitchFamily="34" charset="-120"/>
-              </a:rPr>
-              <a:t>silent</a:t>
-            </a:r>
-            <a:endParaRPr lang="en-US" sz="750" dirty="0"/>
           </a:p>
         </p:txBody>
       </p:sp>
@@ -15910,7 +15976,7 @@
                 <a:ea typeface="Calibri" pitchFamily="34" charset="-122"/>
                 <a:cs typeface="Calibri" pitchFamily="34" charset="-120"/>
               </a:rPr>
-              <a:t>Word Labs  •  wordlabs.app  •  Prefix: 'a-' = on, in, or into a state</a:t>
+              <a:t>Word Labs  •  wordlabs.app  •  Prefix: 'a-' = not, without, on, toward</a:t>
             </a:r>
             <a:endParaRPr lang="en-US" sz="800" dirty="0"/>
           </a:p>
@@ -16550,7 +16616,7 @@
                 <a:ea typeface="Calibri" pitchFamily="34" charset="-122"/>
                 <a:cs typeface="Calibri" pitchFamily="34" charset="-120"/>
               </a:rPr>
-              <a:t>Word Labs  •  wordlabs.app  •  Prefix: 'a-' = on, in, or into a state</a:t>
+              <a:t>Word Labs  •  wordlabs.app  •  Prefix: 'a-' = not, without, on, toward</a:t>
             </a:r>
             <a:endParaRPr lang="en-US" sz="800" dirty="0"/>
           </a:p>
@@ -16662,7 +16728,7 @@
                 <a:ea typeface="Calibri" pitchFamily="34" charset="-122"/>
                 <a:cs typeface="Calibri" pitchFamily="34" charset="-120"/>
               </a:rPr>
-              <a:t>She was </a:t>
+              <a:t>The log was </a:t>
             </a:r>
             <a:pPr algn="l" indent="0" marL="0">
               <a:buNone/>
@@ -16679,7 +16745,7 @@
                 <a:ea typeface="Calibri" pitchFamily="34" charset="-122"/>
                 <a:cs typeface="Calibri" pitchFamily="34" charset="-120"/>
               </a:rPr>
-              <a:t>awake</a:t>
+              <a:t>ablaze</a:t>
             </a:r>
             <a:pPr algn="l" indent="0" marL="0">
               <a:buNone/>
@@ -16693,7 +16759,7 @@
                 <a:ea typeface="Calibri" pitchFamily="34" charset="-122"/>
                 <a:cs typeface="Calibri" pitchFamily="34" charset="-120"/>
               </a:rPr>
-              <a:t> and </a:t>
+              <a:t> on the shore, and the drifting boat stayed </a:t>
             </a:r>
             <a:pPr algn="l" indent="0" marL="0">
               <a:buNone/>
@@ -16710,7 +16776,7 @@
                 <a:ea typeface="Calibri" pitchFamily="34" charset="-122"/>
                 <a:cs typeface="Calibri" pitchFamily="34" charset="-120"/>
               </a:rPr>
-              <a:t>alive</a:t>
+              <a:t>afloat</a:t>
             </a:r>
             <a:pPr algn="l" indent="0" marL="0">
               <a:buNone/>
@@ -16724,118 +16790,343 @@
                 <a:ea typeface="Calibri" pitchFamily="34" charset="-122"/>
                 <a:cs typeface="Calibri" pitchFamily="34" charset="-120"/>
               </a:rPr>
-              <a:t> with excitement as she stepped </a:t>
-            </a:r>
+              <a:t> all night.</a:t>
+            </a:r>
+            <a:endParaRPr lang="en-US" sz="1800" dirty="0"/>
+          </a:p>
+        </p:txBody>
+      </p:sp>
+      <p:sp>
+        <p:nvSpPr>
+          <p:cNvPr id="13" name="Shape 11"/>
+          <p:cNvSpPr/>
+          <p:nvPr/>
+        </p:nvSpPr>
+        <p:spPr>
+          <a:xfrm>
+            <a:off x="365760" y="2852928"/>
+            <a:ext cx="8412480" cy="475488"/>
+          </a:xfrm>
+          <a:prstGeom prst="rect">
+            <a:avLst>
+              <a:gd name="adj" fmla="val 15385"/>
+            </a:avLst>
+          </a:prstGeom>
+          <a:solidFill>
+            <a:srgbClr val="CCFBF1"/>
+          </a:solidFill>
+          <a:ln w="12700">
+            <a:solidFill>
+              <a:srgbClr val="0D9488"/>
+            </a:solidFill>
+            <a:prstDash val="solid"/>
+          </a:ln>
+        </p:spPr>
+      </p:sp>
+      <p:sp>
+        <p:nvSpPr>
+          <p:cNvPr id="14" name="Text 12"/>
+          <p:cNvSpPr/>
+          <p:nvPr/>
+        </p:nvSpPr>
+        <p:spPr>
+          <a:xfrm>
+            <a:off x="502920" y="2852928"/>
+            <a:ext cx="8229600" cy="475488"/>
+          </a:xfrm>
+          <a:prstGeom prst="rect">
+            <a:avLst/>
+          </a:prstGeom>
+          <a:noFill/>
+          <a:ln/>
+        </p:spPr>
+        <p:txBody>
+          <a:bodyPr wrap="square" rtlCol="0" anchor="ctr"/>
+          <a:lstStyle/>
+          <a:p>
             <a:pPr algn="l" indent="0" marL="0">
               <a:buNone/>
             </a:pPr>
             <a:r>
-              <a:rPr lang="en-US" sz="1800" b="1" dirty="0">
-                <a:solidFill>
-                  <a:srgbClr val="0D9488"/>
-                </a:solidFill>
-                <a:highlight>
-                  <a:srgbClr val="CCFBF1"/>
-                </a:highlight>
+              <a:rPr lang="en-US" sz="1200" b="1" dirty="0">
+                <a:solidFill>
+                  <a:srgbClr val="0F766E"/>
+                </a:solidFill>
                 <a:latin typeface="Calibri" pitchFamily="34" charset="0"/>
                 <a:ea typeface="Calibri" pitchFamily="34" charset="-122"/>
                 <a:cs typeface="Calibri" pitchFamily="34" charset="-120"/>
               </a:rPr>
-              <a:t>aboard</a:t>
-            </a:r>
-            <a:pPr algn="l" indent="0" marL="0">
-              <a:buNone/>
-            </a:pPr>
-            <a:r>
-              <a:rPr lang="en-US" sz="1800" dirty="0">
-                <a:solidFill>
-                  <a:srgbClr val="0F172A"/>
+              <a:t>Now rewrite each focus word below with space between letters — leave room for your breakdown.</a:t>
+            </a:r>
+            <a:endParaRPr lang="en-US" sz="1200" dirty="0"/>
+          </a:p>
+        </p:txBody>
+      </p:sp>
+      <p:sp>
+        <p:nvSpPr>
+          <p:cNvPr id="15" name="Shape 13"/>
+          <p:cNvSpPr/>
+          <p:nvPr/>
+        </p:nvSpPr>
+        <p:spPr>
+          <a:xfrm>
+            <a:off x="411480" y="3456432"/>
+            <a:ext cx="2499360" cy="1005840"/>
+          </a:xfrm>
+          <a:prstGeom prst="rect">
+            <a:avLst>
+              <a:gd name="adj" fmla="val 7273"/>
+            </a:avLst>
+          </a:prstGeom>
+          <a:solidFill>
+            <a:srgbClr val="F8FAFC"/>
+          </a:solidFill>
+          <a:ln w="12700">
+            <a:solidFill>
+              <a:srgbClr val="E2E8F0"/>
+            </a:solidFill>
+            <a:prstDash val="solid"/>
+          </a:ln>
+        </p:spPr>
+      </p:sp>
+      <p:sp>
+        <p:nvSpPr>
+          <p:cNvPr id="16" name="Shape 14"/>
+          <p:cNvSpPr/>
+          <p:nvPr/>
+        </p:nvSpPr>
+        <p:spPr>
+          <a:xfrm>
+            <a:off x="411480" y="3977640"/>
+            <a:ext cx="2499360" cy="0"/>
+          </a:xfrm>
+          <a:prstGeom prst="line">
+            <a:avLst/>
+          </a:prstGeom>
+          <a:noFill/>
+          <a:ln w="12700">
+            <a:solidFill>
+              <a:srgbClr val="E2E8F0"/>
+            </a:solidFill>
+            <a:prstDash val="dash"/>
+          </a:ln>
+        </p:spPr>
+      </p:sp>
+      <p:sp>
+        <p:nvSpPr>
+          <p:cNvPr id="17" name="Text 15"/>
+          <p:cNvSpPr/>
+          <p:nvPr/>
+        </p:nvSpPr>
+        <p:spPr>
+          <a:xfrm>
+            <a:off x="411480" y="3456432"/>
+            <a:ext cx="2499360" cy="502920"/>
+          </a:xfrm>
+          <a:prstGeom prst="rect">
+            <a:avLst/>
+          </a:prstGeom>
+          <a:noFill/>
+          <a:ln/>
+        </p:spPr>
+        <p:txBody>
+          <a:bodyPr wrap="square" lIns="0" tIns="0" rIns="0" bIns="0" rtlCol="0" anchor="ctr"/>
+          <a:lstStyle/>
+          <a:p>
+            <a:pPr algn="ctr" indent="0" marL="0">
+              <a:buNone/>
+            </a:pPr>
+            <a:r>
+              <a:rPr lang="en-US" sz="1400" b="1" dirty="0">
+                <a:solidFill>
+                  <a:srgbClr val="0D9488"/>
+                </a:solidFill>
+                <a:latin typeface="Trebuchet MS" pitchFamily="34" charset="0"/>
+                <a:ea typeface="Trebuchet MS" pitchFamily="34" charset="-122"/>
+                <a:cs typeface="Trebuchet MS" pitchFamily="34" charset="-120"/>
+              </a:rPr>
+              <a:t>ablaze</a:t>
+            </a:r>
+            <a:endParaRPr lang="en-US" sz="1400" dirty="0"/>
+          </a:p>
+        </p:txBody>
+      </p:sp>
+      <p:sp>
+        <p:nvSpPr>
+          <p:cNvPr id="18" name="Text 16"/>
+          <p:cNvSpPr/>
+          <p:nvPr/>
+        </p:nvSpPr>
+        <p:spPr>
+          <a:xfrm>
+            <a:off x="411480" y="4005072"/>
+            <a:ext cx="2499360" cy="457200"/>
+          </a:xfrm>
+          <a:prstGeom prst="rect">
+            <a:avLst/>
+          </a:prstGeom>
+          <a:noFill/>
+          <a:ln/>
+        </p:spPr>
+        <p:txBody>
+          <a:bodyPr wrap="square" lIns="0" tIns="0" rIns="0" bIns="0" rtlCol="0" anchor="ctr"/>
+          <a:lstStyle/>
+          <a:p>
+            <a:pPr algn="ctr" indent="0" marL="0">
+              <a:buNone/>
+            </a:pPr>
+            <a:r>
+              <a:rPr lang="en-US" sz="900" i="1" dirty="0">
+                <a:solidFill>
+                  <a:srgbClr val="475569"/>
                 </a:solidFill>
                 <a:latin typeface="Calibri" pitchFamily="34" charset="0"/>
                 <a:ea typeface="Calibri" pitchFamily="34" charset="-122"/>
                 <a:cs typeface="Calibri" pitchFamily="34" charset="-120"/>
               </a:rPr>
-              <a:t> the tall ship for the very first time.</a:t>
-            </a:r>
-            <a:endParaRPr lang="en-US" sz="1800" dirty="0"/>
-          </a:p>
-        </p:txBody>
-      </p:sp>
-      <p:sp>
-        <p:nvSpPr>
-          <p:cNvPr id="13" name="Shape 11"/>
-          <p:cNvSpPr/>
-          <p:nvPr/>
-        </p:nvSpPr>
-        <p:spPr>
-          <a:xfrm>
-            <a:off x="365760" y="2852928"/>
-            <a:ext cx="8412480" cy="475488"/>
+              <a:t>write your breakdown below</a:t>
+            </a:r>
+            <a:endParaRPr lang="en-US" sz="900" dirty="0"/>
+          </a:p>
+        </p:txBody>
+      </p:sp>
+      <p:sp>
+        <p:nvSpPr>
+          <p:cNvPr id="19" name="Shape 17"/>
+          <p:cNvSpPr/>
+          <p:nvPr/>
+        </p:nvSpPr>
+        <p:spPr>
+          <a:xfrm>
+            <a:off x="3185160" y="3456432"/>
+            <a:ext cx="2499360" cy="1005840"/>
           </a:xfrm>
           <a:prstGeom prst="rect">
             <a:avLst>
-              <a:gd name="adj" fmla="val 15385"/>
+              <a:gd name="adj" fmla="val 7273"/>
             </a:avLst>
           </a:prstGeom>
           <a:solidFill>
-            <a:srgbClr val="CCFBF1"/>
-          </a:solidFill>
-          <a:ln w="12700">
-            <a:solidFill>
-              <a:srgbClr val="0D9488"/>
-            </a:solidFill>
-            <a:prstDash val="solid"/>
-          </a:ln>
-        </p:spPr>
-      </p:sp>
-      <p:sp>
-        <p:nvSpPr>
-          <p:cNvPr id="14" name="Text 12"/>
-          <p:cNvSpPr/>
-          <p:nvPr/>
-        </p:nvSpPr>
-        <p:spPr>
-          <a:xfrm>
-            <a:off x="502920" y="2852928"/>
-            <a:ext cx="8229600" cy="475488"/>
-          </a:xfrm>
-          <a:prstGeom prst="rect">
-            <a:avLst/>
-          </a:prstGeom>
-          <a:noFill/>
-          <a:ln/>
-        </p:spPr>
-        <p:txBody>
-          <a:bodyPr wrap="square" rtlCol="0" anchor="ctr"/>
-          <a:lstStyle/>
-          <a:p>
-            <a:pPr algn="l" indent="0" marL="0">
-              <a:buNone/>
-            </a:pPr>
-            <a:r>
-              <a:rPr lang="en-US" sz="1200" b="1" dirty="0">
-                <a:solidFill>
-                  <a:srgbClr val="0F766E"/>
+            <a:srgbClr val="F8FAFC"/>
+          </a:solidFill>
+          <a:ln w="12700">
+            <a:solidFill>
+              <a:srgbClr val="E2E8F0"/>
+            </a:solidFill>
+            <a:prstDash val="solid"/>
+          </a:ln>
+        </p:spPr>
+      </p:sp>
+      <p:sp>
+        <p:nvSpPr>
+          <p:cNvPr id="20" name="Shape 18"/>
+          <p:cNvSpPr/>
+          <p:nvPr/>
+        </p:nvSpPr>
+        <p:spPr>
+          <a:xfrm>
+            <a:off x="3185160" y="3977640"/>
+            <a:ext cx="2499360" cy="0"/>
+          </a:xfrm>
+          <a:prstGeom prst="line">
+            <a:avLst/>
+          </a:prstGeom>
+          <a:noFill/>
+          <a:ln w="12700">
+            <a:solidFill>
+              <a:srgbClr val="E2E8F0"/>
+            </a:solidFill>
+            <a:prstDash val="dash"/>
+          </a:ln>
+        </p:spPr>
+      </p:sp>
+      <p:sp>
+        <p:nvSpPr>
+          <p:cNvPr id="21" name="Text 19"/>
+          <p:cNvSpPr/>
+          <p:nvPr/>
+        </p:nvSpPr>
+        <p:spPr>
+          <a:xfrm>
+            <a:off x="3185160" y="3456432"/>
+            <a:ext cx="2499360" cy="502920"/>
+          </a:xfrm>
+          <a:prstGeom prst="rect">
+            <a:avLst/>
+          </a:prstGeom>
+          <a:noFill/>
+          <a:ln/>
+        </p:spPr>
+        <p:txBody>
+          <a:bodyPr wrap="square" lIns="0" tIns="0" rIns="0" bIns="0" rtlCol="0" anchor="ctr"/>
+          <a:lstStyle/>
+          <a:p>
+            <a:pPr algn="ctr" indent="0" marL="0">
+              <a:buNone/>
+            </a:pPr>
+            <a:r>
+              <a:rPr lang="en-US" sz="1400" b="1" dirty="0">
+                <a:solidFill>
+                  <a:srgbClr val="0D9488"/>
+                </a:solidFill>
+                <a:latin typeface="Trebuchet MS" pitchFamily="34" charset="0"/>
+                <a:ea typeface="Trebuchet MS" pitchFamily="34" charset="-122"/>
+                <a:cs typeface="Trebuchet MS" pitchFamily="34" charset="-120"/>
+              </a:rPr>
+              <a:t>ashore</a:t>
+            </a:r>
+            <a:endParaRPr lang="en-US" sz="1400" dirty="0"/>
+          </a:p>
+        </p:txBody>
+      </p:sp>
+      <p:sp>
+        <p:nvSpPr>
+          <p:cNvPr id="22" name="Text 20"/>
+          <p:cNvSpPr/>
+          <p:nvPr/>
+        </p:nvSpPr>
+        <p:spPr>
+          <a:xfrm>
+            <a:off x="3185160" y="4005072"/>
+            <a:ext cx="2499360" cy="457200"/>
+          </a:xfrm>
+          <a:prstGeom prst="rect">
+            <a:avLst/>
+          </a:prstGeom>
+          <a:noFill/>
+          <a:ln/>
+        </p:spPr>
+        <p:txBody>
+          <a:bodyPr wrap="square" lIns="0" tIns="0" rIns="0" bIns="0" rtlCol="0" anchor="ctr"/>
+          <a:lstStyle/>
+          <a:p>
+            <a:pPr algn="ctr" indent="0" marL="0">
+              <a:buNone/>
+            </a:pPr>
+            <a:r>
+              <a:rPr lang="en-US" sz="900" i="1" dirty="0">
+                <a:solidFill>
+                  <a:srgbClr val="475569"/>
                 </a:solidFill>
                 <a:latin typeface="Calibri" pitchFamily="34" charset="0"/>
                 <a:ea typeface="Calibri" pitchFamily="34" charset="-122"/>
                 <a:cs typeface="Calibri" pitchFamily="34" charset="-120"/>
               </a:rPr>
-              <a:t>Now rewrite each focus word below with space between letters — leave room for your breakdown.</a:t>
-            </a:r>
-            <a:endParaRPr lang="en-US" sz="1200" dirty="0"/>
-          </a:p>
-        </p:txBody>
-      </p:sp>
-      <p:sp>
-        <p:nvSpPr>
-          <p:cNvPr id="15" name="Shape 13"/>
-          <p:cNvSpPr/>
-          <p:nvPr/>
-        </p:nvSpPr>
-        <p:spPr>
-          <a:xfrm>
-            <a:off x="411480" y="3456432"/>
+              <a:t>write your breakdown below</a:t>
+            </a:r>
+            <a:endParaRPr lang="en-US" sz="900" dirty="0"/>
+          </a:p>
+        </p:txBody>
+      </p:sp>
+      <p:sp>
+        <p:nvSpPr>
+          <p:cNvPr id="23" name="Shape 21"/>
+          <p:cNvSpPr/>
+          <p:nvPr/>
+        </p:nvSpPr>
+        <p:spPr>
+          <a:xfrm>
+            <a:off x="5958840" y="3456432"/>
             <a:ext cx="2499360" cy="1005840"/>
           </a:xfrm>
           <a:prstGeom prst="rect">
@@ -16856,13 +17147,13 @@
       </p:sp>
       <p:sp>
         <p:nvSpPr>
-          <p:cNvPr id="16" name="Shape 14"/>
-          <p:cNvSpPr/>
-          <p:nvPr/>
-        </p:nvSpPr>
-        <p:spPr>
-          <a:xfrm>
-            <a:off x="411480" y="3977640"/>
+          <p:cNvPr id="24" name="Shape 22"/>
+          <p:cNvSpPr/>
+          <p:nvPr/>
+        </p:nvSpPr>
+        <p:spPr>
+          <a:xfrm>
+            <a:off x="5958840" y="3977640"/>
             <a:ext cx="2499360" cy="0"/>
           </a:xfrm>
           <a:prstGeom prst="line">
@@ -16879,13 +17170,13 @@
       </p:sp>
       <p:sp>
         <p:nvSpPr>
-          <p:cNvPr id="17" name="Text 15"/>
-          <p:cNvSpPr/>
-          <p:nvPr/>
-        </p:nvSpPr>
-        <p:spPr>
-          <a:xfrm>
-            <a:off x="411480" y="3456432"/>
+          <p:cNvPr id="25" name="Text 23"/>
+          <p:cNvSpPr/>
+          <p:nvPr/>
+        </p:nvSpPr>
+        <p:spPr>
+          <a:xfrm>
+            <a:off x="5958840" y="3456432"/>
             <a:ext cx="2499360" cy="502920"/>
           </a:xfrm>
           <a:prstGeom prst="rect">
@@ -16910,263 +17201,7 @@
                 <a:ea typeface="Trebuchet MS" pitchFamily="34" charset="-122"/>
                 <a:cs typeface="Trebuchet MS" pitchFamily="34" charset="-120"/>
               </a:rPr>
-              <a:t>awake</a:t>
-            </a:r>
-            <a:endParaRPr lang="en-US" sz="1400" dirty="0"/>
-          </a:p>
-        </p:txBody>
-      </p:sp>
-      <p:sp>
-        <p:nvSpPr>
-          <p:cNvPr id="18" name="Text 16"/>
-          <p:cNvSpPr/>
-          <p:nvPr/>
-        </p:nvSpPr>
-        <p:spPr>
-          <a:xfrm>
-            <a:off x="411480" y="4005072"/>
-            <a:ext cx="2499360" cy="457200"/>
-          </a:xfrm>
-          <a:prstGeom prst="rect">
-            <a:avLst/>
-          </a:prstGeom>
-          <a:noFill/>
-          <a:ln/>
-        </p:spPr>
-        <p:txBody>
-          <a:bodyPr wrap="square" lIns="0" tIns="0" rIns="0" bIns="0" rtlCol="0" anchor="ctr"/>
-          <a:lstStyle/>
-          <a:p>
-            <a:pPr algn="ctr" indent="0" marL="0">
-              <a:buNone/>
-            </a:pPr>
-            <a:r>
-              <a:rPr lang="en-US" sz="900" i="1" dirty="0">
-                <a:solidFill>
-                  <a:srgbClr val="475569"/>
-                </a:solidFill>
-                <a:latin typeface="Calibri" pitchFamily="34" charset="0"/>
-                <a:ea typeface="Calibri" pitchFamily="34" charset="-122"/>
-                <a:cs typeface="Calibri" pitchFamily="34" charset="-120"/>
-              </a:rPr>
-              <a:t>write your breakdown below</a:t>
-            </a:r>
-            <a:endParaRPr lang="en-US" sz="900" dirty="0"/>
-          </a:p>
-        </p:txBody>
-      </p:sp>
-      <p:sp>
-        <p:nvSpPr>
-          <p:cNvPr id="19" name="Shape 17"/>
-          <p:cNvSpPr/>
-          <p:nvPr/>
-        </p:nvSpPr>
-        <p:spPr>
-          <a:xfrm>
-            <a:off x="3185160" y="3456432"/>
-            <a:ext cx="2499360" cy="1005840"/>
-          </a:xfrm>
-          <a:prstGeom prst="rect">
-            <a:avLst>
-              <a:gd name="adj" fmla="val 7273"/>
-            </a:avLst>
-          </a:prstGeom>
-          <a:solidFill>
-            <a:srgbClr val="F8FAFC"/>
-          </a:solidFill>
-          <a:ln w="12700">
-            <a:solidFill>
-              <a:srgbClr val="E2E8F0"/>
-            </a:solidFill>
-            <a:prstDash val="solid"/>
-          </a:ln>
-        </p:spPr>
-      </p:sp>
-      <p:sp>
-        <p:nvSpPr>
-          <p:cNvPr id="20" name="Shape 18"/>
-          <p:cNvSpPr/>
-          <p:nvPr/>
-        </p:nvSpPr>
-        <p:spPr>
-          <a:xfrm>
-            <a:off x="3185160" y="3977640"/>
-            <a:ext cx="2499360" cy="0"/>
-          </a:xfrm>
-          <a:prstGeom prst="line">
-            <a:avLst/>
-          </a:prstGeom>
-          <a:noFill/>
-          <a:ln w="12700">
-            <a:solidFill>
-              <a:srgbClr val="E2E8F0"/>
-            </a:solidFill>
-            <a:prstDash val="dash"/>
-          </a:ln>
-        </p:spPr>
-      </p:sp>
-      <p:sp>
-        <p:nvSpPr>
-          <p:cNvPr id="21" name="Text 19"/>
-          <p:cNvSpPr/>
-          <p:nvPr/>
-        </p:nvSpPr>
-        <p:spPr>
-          <a:xfrm>
-            <a:off x="3185160" y="3456432"/>
-            <a:ext cx="2499360" cy="502920"/>
-          </a:xfrm>
-          <a:prstGeom prst="rect">
-            <a:avLst/>
-          </a:prstGeom>
-          <a:noFill/>
-          <a:ln/>
-        </p:spPr>
-        <p:txBody>
-          <a:bodyPr wrap="square" lIns="0" tIns="0" rIns="0" bIns="0" rtlCol="0" anchor="ctr"/>
-          <a:lstStyle/>
-          <a:p>
-            <a:pPr algn="ctr" indent="0" marL="0">
-              <a:buNone/>
-            </a:pPr>
-            <a:r>
-              <a:rPr lang="en-US" sz="1400" b="1" dirty="0">
-                <a:solidFill>
-                  <a:srgbClr val="0D9488"/>
-                </a:solidFill>
-                <a:latin typeface="Trebuchet MS" pitchFamily="34" charset="0"/>
-                <a:ea typeface="Trebuchet MS" pitchFamily="34" charset="-122"/>
-                <a:cs typeface="Trebuchet MS" pitchFamily="34" charset="-120"/>
-              </a:rPr>
-              <a:t>alive</a:t>
-            </a:r>
-            <a:endParaRPr lang="en-US" sz="1400" dirty="0"/>
-          </a:p>
-        </p:txBody>
-      </p:sp>
-      <p:sp>
-        <p:nvSpPr>
-          <p:cNvPr id="22" name="Text 20"/>
-          <p:cNvSpPr/>
-          <p:nvPr/>
-        </p:nvSpPr>
-        <p:spPr>
-          <a:xfrm>
-            <a:off x="3185160" y="4005072"/>
-            <a:ext cx="2499360" cy="457200"/>
-          </a:xfrm>
-          <a:prstGeom prst="rect">
-            <a:avLst/>
-          </a:prstGeom>
-          <a:noFill/>
-          <a:ln/>
-        </p:spPr>
-        <p:txBody>
-          <a:bodyPr wrap="square" lIns="0" tIns="0" rIns="0" bIns="0" rtlCol="0" anchor="ctr"/>
-          <a:lstStyle/>
-          <a:p>
-            <a:pPr algn="ctr" indent="0" marL="0">
-              <a:buNone/>
-            </a:pPr>
-            <a:r>
-              <a:rPr lang="en-US" sz="900" i="1" dirty="0">
-                <a:solidFill>
-                  <a:srgbClr val="475569"/>
-                </a:solidFill>
-                <a:latin typeface="Calibri" pitchFamily="34" charset="0"/>
-                <a:ea typeface="Calibri" pitchFamily="34" charset="-122"/>
-                <a:cs typeface="Calibri" pitchFamily="34" charset="-120"/>
-              </a:rPr>
-              <a:t>write your breakdown below</a:t>
-            </a:r>
-            <a:endParaRPr lang="en-US" sz="900" dirty="0"/>
-          </a:p>
-        </p:txBody>
-      </p:sp>
-      <p:sp>
-        <p:nvSpPr>
-          <p:cNvPr id="23" name="Shape 21"/>
-          <p:cNvSpPr/>
-          <p:nvPr/>
-        </p:nvSpPr>
-        <p:spPr>
-          <a:xfrm>
-            <a:off x="5958840" y="3456432"/>
-            <a:ext cx="2499360" cy="1005840"/>
-          </a:xfrm>
-          <a:prstGeom prst="rect">
-            <a:avLst>
-              <a:gd name="adj" fmla="val 7273"/>
-            </a:avLst>
-          </a:prstGeom>
-          <a:solidFill>
-            <a:srgbClr val="F8FAFC"/>
-          </a:solidFill>
-          <a:ln w="12700">
-            <a:solidFill>
-              <a:srgbClr val="E2E8F0"/>
-            </a:solidFill>
-            <a:prstDash val="solid"/>
-          </a:ln>
-        </p:spPr>
-      </p:sp>
-      <p:sp>
-        <p:nvSpPr>
-          <p:cNvPr id="24" name="Shape 22"/>
-          <p:cNvSpPr/>
-          <p:nvPr/>
-        </p:nvSpPr>
-        <p:spPr>
-          <a:xfrm>
-            <a:off x="5958840" y="3977640"/>
-            <a:ext cx="2499360" cy="0"/>
-          </a:xfrm>
-          <a:prstGeom prst="line">
-            <a:avLst/>
-          </a:prstGeom>
-          <a:noFill/>
-          <a:ln w="12700">
-            <a:solidFill>
-              <a:srgbClr val="E2E8F0"/>
-            </a:solidFill>
-            <a:prstDash val="dash"/>
-          </a:ln>
-        </p:spPr>
-      </p:sp>
-      <p:sp>
-        <p:nvSpPr>
-          <p:cNvPr id="25" name="Text 23"/>
-          <p:cNvSpPr/>
-          <p:nvPr/>
-        </p:nvSpPr>
-        <p:spPr>
-          <a:xfrm>
-            <a:off x="5958840" y="3456432"/>
-            <a:ext cx="2499360" cy="502920"/>
-          </a:xfrm>
-          <a:prstGeom prst="rect">
-            <a:avLst/>
-          </a:prstGeom>
-          <a:noFill/>
-          <a:ln/>
-        </p:spPr>
-        <p:txBody>
-          <a:bodyPr wrap="square" lIns="0" tIns="0" rIns="0" bIns="0" rtlCol="0" anchor="ctr"/>
-          <a:lstStyle/>
-          <a:p>
-            <a:pPr algn="ctr" indent="0" marL="0">
-              <a:buNone/>
-            </a:pPr>
-            <a:r>
-              <a:rPr lang="en-US" sz="1400" b="1" dirty="0">
-                <a:solidFill>
-                  <a:srgbClr val="0D9488"/>
-                </a:solidFill>
-                <a:latin typeface="Trebuchet MS" pitchFamily="34" charset="0"/>
-                <a:ea typeface="Trebuchet MS" pitchFamily="34" charset="-122"/>
-                <a:cs typeface="Trebuchet MS" pitchFamily="34" charset="-120"/>
-              </a:rPr>
-              <a:t>aboard</a:t>
+              <a:t>afloat</a:t>
             </a:r>
             <a:endParaRPr lang="en-US" sz="1400" dirty="0"/>
           </a:p>
@@ -17497,7 +17532,7 @@
                 <a:ea typeface="Calibri" pitchFamily="34" charset="-122"/>
                 <a:cs typeface="Calibri" pitchFamily="34" charset="-120"/>
               </a:rPr>
-              <a:t>Word Labs  •  wordlabs.app  •  Prefix: 'a-' = on, in, or into a state</a:t>
+              <a:t>Word Labs  •  wordlabs.app  •  Prefix: 'a-' = not, without, on, toward</a:t>
             </a:r>
             <a:endParaRPr lang="en-US" sz="800" dirty="0"/>
           </a:p>
@@ -17636,7 +17671,7 @@
                 <a:ea typeface="Trebuchet MS" pitchFamily="34" charset="-122"/>
                 <a:cs typeface="Trebuchet MS" pitchFamily="34" charset="-120"/>
               </a:rPr>
-              <a:t>awake</a:t>
+              <a:t>ablaze</a:t>
             </a:r>
             <a:endParaRPr lang="en-US" sz="2800" dirty="0"/>
           </a:p>
@@ -18324,7 +18359,7 @@
                 <a:ea typeface="Calibri" pitchFamily="34" charset="-122"/>
                 <a:cs typeface="Calibri" pitchFamily="34" charset="-120"/>
               </a:rPr>
-              <a:t>Word Labs  •  wordlabs.app  •  Prefix: 'a-' = on, in, or into a state</a:t>
+              <a:t>Word Labs  •  wordlabs.app  •  Prefix: 'a-' = not, without, on, toward</a:t>
             </a:r>
             <a:endParaRPr lang="en-US" sz="800" dirty="0"/>
           </a:p>
@@ -18463,7 +18498,7 @@
                 <a:ea typeface="Trebuchet MS" pitchFamily="34" charset="-122"/>
                 <a:cs typeface="Trebuchet MS" pitchFamily="34" charset="-120"/>
               </a:rPr>
-              <a:t>awake</a:t>
+              <a:t>ablaze</a:t>
             </a:r>
             <a:endParaRPr lang="en-US" sz="2800" dirty="0"/>
           </a:p>
@@ -18664,11 +18699,11 @@
             </a:avLst>
           </a:prstGeom>
           <a:solidFill>
-            <a:srgbClr val="DDD6FE"/>
+            <a:srgbClr val="FCE7F3"/>
           </a:solidFill>
           <a:ln w="19050">
             <a:solidFill>
-              <a:srgbClr val="7C3AED"/>
+              <a:srgbClr val="DB2777"/>
             </a:solidFill>
             <a:prstDash val="solid"/>
           </a:ln>
@@ -18708,13 +18743,13 @@
             <a:r>
               <a:rPr lang="en-US" sz="1300" b="1" dirty="0">
                 <a:solidFill>
-                  <a:srgbClr val="4C1D95"/>
+                  <a:srgbClr val="9D174D"/>
                 </a:solidFill>
                 <a:latin typeface="Trebuchet MS" pitchFamily="34" charset="0"/>
                 <a:ea typeface="Trebuchet MS" pitchFamily="34" charset="-122"/>
                 <a:cs typeface="Trebuchet MS" pitchFamily="34" charset="-120"/>
               </a:rPr>
-              <a:t>wake</a:t>
+              <a:t>blaze</a:t>
             </a:r>
             <a:endParaRPr lang="en-US" sz="1300" dirty="0"/>
           </a:p>
@@ -18753,7 +18788,7 @@
                 <a:ea typeface="Calibri" pitchFamily="34" charset="-122"/>
                 <a:cs typeface="Calibri" pitchFamily="34" charset="-120"/>
               </a:rPr>
-              <a:t>not sleeping</a:t>
+              <a:t>a bright fire or flame</a:t>
             </a:r>
             <a:endParaRPr lang="en-US" sz="850" dirty="0"/>
           </a:p>
@@ -19309,7 +19344,7 @@
                 <a:ea typeface="Calibri" pitchFamily="34" charset="-122"/>
                 <a:cs typeface="Calibri" pitchFamily="34" charset="-120"/>
               </a:rPr>
-              <a:t>Word Labs  •  wordlabs.app  •  Prefix: 'a-' = on, in, or into a state</a:t>
+              <a:t>Word Labs  •  wordlabs.app  •  Prefix: 'a-' = not, without, on, toward</a:t>
             </a:r>
             <a:endParaRPr lang="en-US" sz="800" dirty="0"/>
           </a:p>
@@ -19448,7 +19483,7 @@
                 <a:ea typeface="Trebuchet MS" pitchFamily="34" charset="-122"/>
                 <a:cs typeface="Trebuchet MS" pitchFamily="34" charset="-120"/>
               </a:rPr>
-              <a:t>awake</a:t>
+              <a:t>ablaze</a:t>
             </a:r>
             <a:endParaRPr lang="en-US" sz="2800" dirty="0"/>
           </a:p>
@@ -19649,11 +19684,11 @@
             </a:avLst>
           </a:prstGeom>
           <a:solidFill>
-            <a:srgbClr val="DDD6FE"/>
+            <a:srgbClr val="FCE7F3"/>
           </a:solidFill>
           <a:ln w="19050">
             <a:solidFill>
-              <a:srgbClr val="7C3AED"/>
+              <a:srgbClr val="DB2777"/>
             </a:solidFill>
             <a:prstDash val="solid"/>
           </a:ln>
@@ -19693,13 +19728,13 @@
             <a:r>
               <a:rPr lang="en-US" sz="1300" b="1" dirty="0">
                 <a:solidFill>
-                  <a:srgbClr val="4C1D95"/>
+                  <a:srgbClr val="9D174D"/>
                 </a:solidFill>
                 <a:latin typeface="Trebuchet MS" pitchFamily="34" charset="0"/>
                 <a:ea typeface="Trebuchet MS" pitchFamily="34" charset="-122"/>
                 <a:cs typeface="Trebuchet MS" pitchFamily="34" charset="-120"/>
               </a:rPr>
-              <a:t>wake</a:t>
+              <a:t>blaze</a:t>
             </a:r>
             <a:endParaRPr lang="en-US" sz="1300" dirty="0"/>
           </a:p>
@@ -19738,7 +19773,7 @@
                 <a:ea typeface="Calibri" pitchFamily="34" charset="-122"/>
                 <a:cs typeface="Calibri" pitchFamily="34" charset="-120"/>
               </a:rPr>
-              <a:t>not sleeping</a:t>
+              <a:t>a bright fire or flame</a:t>
             </a:r>
             <a:endParaRPr lang="en-US" sz="850" dirty="0"/>
           </a:p>
@@ -20002,7 +20037,7 @@
                 <a:ea typeface="Trebuchet MS" pitchFamily="34" charset="-122"/>
                 <a:cs typeface="Trebuchet MS" pitchFamily="34" charset="-120"/>
               </a:rPr>
-              <a:t>wake</a:t>
+              <a:t>blaze</a:t>
             </a:r>
             <a:endParaRPr lang="en-US" sz="1400" dirty="0"/>
           </a:p>
@@ -20426,7 +20461,7 @@
                 <a:ea typeface="Calibri" pitchFamily="34" charset="-122"/>
                 <a:cs typeface="Calibri" pitchFamily="34" charset="-120"/>
               </a:rPr>
-              <a:t>Word Labs  •  wordlabs.app  •  Prefix: 'a-' = on, in, or into a state</a:t>
+              <a:t>Word Labs  •  wordlabs.app  •  Prefix: 'a-' = not, without, on, toward</a:t>
             </a:r>
             <a:endParaRPr lang="en-US" sz="800" dirty="0"/>
           </a:p>
@@ -20565,7 +20600,7 @@
                 <a:ea typeface="Trebuchet MS" pitchFamily="34" charset="-122"/>
                 <a:cs typeface="Trebuchet MS" pitchFamily="34" charset="-120"/>
               </a:rPr>
-              <a:t>awake</a:t>
+              <a:t>ablaze</a:t>
             </a:r>
             <a:endParaRPr lang="en-US" sz="2800" dirty="0"/>
           </a:p>
@@ -20766,11 +20801,11 @@
             </a:avLst>
           </a:prstGeom>
           <a:solidFill>
-            <a:srgbClr val="DDD6FE"/>
+            <a:srgbClr val="FCE7F3"/>
           </a:solidFill>
           <a:ln w="19050">
             <a:solidFill>
-              <a:srgbClr val="7C3AED"/>
+              <a:srgbClr val="DB2777"/>
             </a:solidFill>
             <a:prstDash val="solid"/>
           </a:ln>
@@ -20810,13 +20845,13 @@
             <a:r>
               <a:rPr lang="en-US" sz="1300" b="1" dirty="0">
                 <a:solidFill>
-                  <a:srgbClr val="4C1D95"/>
+                  <a:srgbClr val="9D174D"/>
                 </a:solidFill>
                 <a:latin typeface="Trebuchet MS" pitchFamily="34" charset="0"/>
                 <a:ea typeface="Trebuchet MS" pitchFamily="34" charset="-122"/>
                 <a:cs typeface="Trebuchet MS" pitchFamily="34" charset="-120"/>
               </a:rPr>
-              <a:t>wake</a:t>
+              <a:t>blaze</a:t>
             </a:r>
             <a:endParaRPr lang="en-US" sz="1300" dirty="0"/>
           </a:p>
@@ -20855,7 +20890,7 @@
                 <a:ea typeface="Calibri" pitchFamily="34" charset="-122"/>
                 <a:cs typeface="Calibri" pitchFamily="34" charset="-120"/>
               </a:rPr>
-              <a:t>not sleeping</a:t>
+              <a:t>a bright fire or flame</a:t>
             </a:r>
             <a:endParaRPr lang="en-US" sz="850" dirty="0"/>
           </a:p>
@@ -21119,7 +21154,7 @@
                 <a:ea typeface="Trebuchet MS" pitchFamily="34" charset="-122"/>
                 <a:cs typeface="Trebuchet MS" pitchFamily="34" charset="-120"/>
               </a:rPr>
-              <a:t>wake</a:t>
+              <a:t>blaze</a:t>
             </a:r>
             <a:endParaRPr lang="en-US" sz="1400" dirty="0"/>
           </a:p>
@@ -21226,7 +21261,7 @@
         </p:nvSpPr>
         <p:spPr>
           <a:xfrm>
-            <a:off x="2670048" y="4169664"/>
+            <a:off x="2427732" y="4169664"/>
             <a:ext cx="685800" cy="384048"/>
           </a:xfrm>
           <a:prstGeom prst="rect">
@@ -21253,7 +21288,7 @@
         </p:nvSpPr>
         <p:spPr>
           <a:xfrm>
-            <a:off x="2670048" y="4169664"/>
+            <a:off x="2427732" y="4169664"/>
             <a:ext cx="685800" cy="384048"/>
           </a:xfrm>
           <a:prstGeom prst="rect">
@@ -21292,7 +21327,7 @@
         </p:nvSpPr>
         <p:spPr>
           <a:xfrm>
-            <a:off x="4123944" y="4169664"/>
+            <a:off x="3639312" y="4169664"/>
             <a:ext cx="685800" cy="384048"/>
           </a:xfrm>
           <a:prstGeom prst="rect">
@@ -21319,7 +21354,7 @@
         </p:nvSpPr>
         <p:spPr>
           <a:xfrm>
-            <a:off x="4123944" y="4169664"/>
+            <a:off x="3639312" y="4169664"/>
             <a:ext cx="685800" cy="384048"/>
           </a:xfrm>
           <a:prstGeom prst="rect">
@@ -21344,7 +21379,7 @@
                 <a:ea typeface="Trebuchet MS" pitchFamily="34" charset="-122"/>
                 <a:cs typeface="Trebuchet MS" pitchFamily="34" charset="-120"/>
               </a:rPr>
-              <a:t>w</a:t>
+              <a:t>b</a:t>
             </a:r>
             <a:endParaRPr lang="en-US" sz="900" dirty="0"/>
           </a:p>
@@ -21358,7 +21393,7 @@
         </p:nvSpPr>
         <p:spPr>
           <a:xfrm>
-            <a:off x="5577840" y="4169664"/>
+            <a:off x="4850892" y="4169664"/>
             <a:ext cx="685800" cy="384048"/>
           </a:xfrm>
           <a:prstGeom prst="rect">
@@ -21385,7 +21420,7 @@
         </p:nvSpPr>
         <p:spPr>
           <a:xfrm>
-            <a:off x="5577840" y="4169664"/>
+            <a:off x="4850892" y="4169664"/>
             <a:ext cx="685800" cy="384048"/>
           </a:xfrm>
           <a:prstGeom prst="rect">
@@ -21410,7 +21445,7 @@
                 <a:ea typeface="Trebuchet MS" pitchFamily="34" charset="-122"/>
                 <a:cs typeface="Trebuchet MS" pitchFamily="34" charset="-120"/>
               </a:rPr>
-              <a:t>a</a:t>
+              <a:t>l</a:t>
             </a:r>
             <a:endParaRPr lang="en-US" sz="900" dirty="0"/>
           </a:p>
@@ -21424,7 +21459,7 @@
         </p:nvSpPr>
         <p:spPr>
           <a:xfrm>
-            <a:off x="7031736" y="4169664"/>
+            <a:off x="6062472" y="4169664"/>
             <a:ext cx="685800" cy="384048"/>
           </a:xfrm>
           <a:prstGeom prst="rect">
@@ -21451,7 +21486,7 @@
         </p:nvSpPr>
         <p:spPr>
           <a:xfrm>
-            <a:off x="7031736" y="4169664"/>
+            <a:off x="6062472" y="4169664"/>
             <a:ext cx="685800" cy="384048"/>
           </a:xfrm>
           <a:prstGeom prst="rect">
@@ -21476,7 +21511,7 @@
                 <a:ea typeface="Trebuchet MS" pitchFamily="34" charset="-122"/>
                 <a:cs typeface="Trebuchet MS" pitchFamily="34" charset="-120"/>
               </a:rPr>
-              <a:t>ke</a:t>
+              <a:t>a</a:t>
             </a:r>
             <a:endParaRPr lang="en-US" sz="900" dirty="0"/>
           </a:p>
@@ -21484,13 +21519,79 @@
       </p:sp>
       <p:sp>
         <p:nvSpPr>
-          <p:cNvPr id="41" name="Text 39"/>
-          <p:cNvSpPr/>
-          <p:nvPr/>
-        </p:nvSpPr>
-        <p:spPr>
-          <a:xfrm>
-            <a:off x="7031736" y="4572000"/>
+          <p:cNvPr id="41" name="Shape 39"/>
+          <p:cNvSpPr/>
+          <p:nvPr/>
+        </p:nvSpPr>
+        <p:spPr>
+          <a:xfrm>
+            <a:off x="7274052" y="4169664"/>
+            <a:ext cx="685800" cy="384048"/>
+          </a:xfrm>
+          <a:prstGeom prst="rect">
+            <a:avLst>
+              <a:gd name="adj" fmla="val 9524"/>
+            </a:avLst>
+          </a:prstGeom>
+          <a:solidFill>
+            <a:srgbClr val="FFFFFF"/>
+          </a:solidFill>
+          <a:ln w="12700">
+            <a:solidFill>
+              <a:srgbClr val="DB2777"/>
+            </a:solidFill>
+            <a:prstDash val="solid"/>
+          </a:ln>
+        </p:spPr>
+      </p:sp>
+      <p:sp>
+        <p:nvSpPr>
+          <p:cNvPr id="42" name="Text 40"/>
+          <p:cNvSpPr/>
+          <p:nvPr/>
+        </p:nvSpPr>
+        <p:spPr>
+          <a:xfrm>
+            <a:off x="7274052" y="4169664"/>
+            <a:ext cx="685800" cy="384048"/>
+          </a:xfrm>
+          <a:prstGeom prst="rect">
+            <a:avLst/>
+          </a:prstGeom>
+          <a:noFill/>
+          <a:ln/>
+        </p:spPr>
+        <p:txBody>
+          <a:bodyPr wrap="square" lIns="0" tIns="0" rIns="0" bIns="0" rtlCol="0" anchor="ctr"/>
+          <a:lstStyle/>
+          <a:p>
+            <a:pPr algn="ctr" indent="0" marL="0">
+              <a:buNone/>
+            </a:pPr>
+            <a:r>
+              <a:rPr lang="en-US" sz="900" b="1" dirty="0">
+                <a:solidFill>
+                  <a:srgbClr val="9D174D"/>
+                </a:solidFill>
+                <a:latin typeface="Trebuchet MS" pitchFamily="34" charset="0"/>
+                <a:ea typeface="Trebuchet MS" pitchFamily="34" charset="-122"/>
+                <a:cs typeface="Trebuchet MS" pitchFamily="34" charset="-120"/>
+              </a:rPr>
+              <a:t>ze</a:t>
+            </a:r>
+            <a:endParaRPr lang="en-US" sz="900" dirty="0"/>
+          </a:p>
+        </p:txBody>
+      </p:sp>
+      <p:sp>
+        <p:nvSpPr>
+          <p:cNvPr id="43" name="Text 41"/>
+          <p:cNvSpPr/>
+          <p:nvPr/>
+        </p:nvSpPr>
+        <p:spPr>
+          <a:xfrm>
+            <a:off x="7274052" y="4572000"/>
             <a:ext cx="685800" cy="219456"/>
           </a:xfrm>
           <a:prstGeom prst="rect">
@@ -21515,7 +21616,7 @@
                 <a:ea typeface="Calibri" pitchFamily="34" charset="-122"/>
                 <a:cs typeface="Calibri" pitchFamily="34" charset="-120"/>
               </a:rPr>
-              <a:t>silent e</a:t>
+              <a:t>/z/</a:t>
             </a:r>
             <a:endParaRPr lang="en-US" sz="750" dirty="0"/>
           </a:p>
@@ -21807,7 +21908,7 @@
                 <a:ea typeface="Calibri" pitchFamily="34" charset="-122"/>
                 <a:cs typeface="Calibri" pitchFamily="34" charset="-120"/>
               </a:rPr>
-              <a:t>Word Labs  •  wordlabs.app  •  Prefix: 'a-' = on, in, or into a state</a:t>
+              <a:t>Word Labs  •  wordlabs.app  •  Prefix: 'a-' = not, without, on, toward</a:t>
             </a:r>
             <a:endParaRPr lang="en-US" sz="800" dirty="0"/>
           </a:p>
@@ -21946,7 +22047,7 @@
                 <a:ea typeface="Trebuchet MS" pitchFamily="34" charset="-122"/>
                 <a:cs typeface="Trebuchet MS" pitchFamily="34" charset="-120"/>
               </a:rPr>
-              <a:t>alive</a:t>
+              <a:t>ashore</a:t>
             </a:r>
             <a:endParaRPr lang="en-US" sz="2800" dirty="0"/>
           </a:p>
@@ -22634,7 +22735,7 @@
                 <a:ea typeface="Calibri" pitchFamily="34" charset="-122"/>
                 <a:cs typeface="Calibri" pitchFamily="34" charset="-120"/>
               </a:rPr>
-              <a:t>Word Labs  •  wordlabs.app  •  Prefix: 'a-' = on, in, or into a state</a:t>
+              <a:t>Word Labs  •  wordlabs.app  •  Prefix: 'a-' = not, without, on, toward</a:t>
             </a:r>
             <a:endParaRPr lang="en-US" sz="800" dirty="0"/>
           </a:p>
@@ -22773,7 +22874,7 @@
                 <a:ea typeface="Trebuchet MS" pitchFamily="34" charset="-122"/>
                 <a:cs typeface="Trebuchet MS" pitchFamily="34" charset="-120"/>
               </a:rPr>
-              <a:t>alive</a:t>
+              <a:t>ashore</a:t>
             </a:r>
             <a:endParaRPr lang="en-US" sz="2800" dirty="0"/>
           </a:p>
@@ -22951,7 +23052,7 @@
                 <a:ea typeface="Calibri" pitchFamily="34" charset="-122"/>
                 <a:cs typeface="Calibri" pitchFamily="34" charset="-120"/>
               </a:rPr>
-              <a:t>in a state of</a:t>
+              <a:t>on or toward</a:t>
             </a:r>
             <a:endParaRPr lang="en-US" sz="850" dirty="0"/>
           </a:p>
@@ -23024,7 +23125,7 @@
                 <a:ea typeface="Trebuchet MS" pitchFamily="34" charset="-122"/>
                 <a:cs typeface="Trebuchet MS" pitchFamily="34" charset="-120"/>
               </a:rPr>
-              <a:t>live</a:t>
+              <a:t>shore</a:t>
             </a:r>
             <a:endParaRPr lang="en-US" sz="1300" dirty="0"/>
           </a:p>
@@ -23063,7 +23164,7 @@
                 <a:ea typeface="Calibri" pitchFamily="34" charset="-122"/>
                 <a:cs typeface="Calibri" pitchFamily="34" charset="-120"/>
               </a:rPr>
-              <a:t>having life</a:t>
+              <a:t>the land at the edge of water</a:t>
             </a:r>
             <a:endParaRPr lang="en-US" sz="850" dirty="0"/>
           </a:p>
@@ -23619,7 +23720,7 @@
                 <a:ea typeface="Calibri" pitchFamily="34" charset="-122"/>
                 <a:cs typeface="Calibri" pitchFamily="34" charset="-120"/>
               </a:rPr>
-              <a:t>Word Labs  •  wordlabs.app  •  Prefix: 'a-' = on, in, or into a state</a:t>
+              <a:t>Word Labs  •  wordlabs.app  •  Prefix: 'a-' = not, without, on, toward</a:t>
             </a:r>
             <a:endParaRPr lang="en-US" sz="800" dirty="0"/>
           </a:p>
@@ -23692,7 +23793,7 @@
                 <a:ea typeface="Trebuchet MS" pitchFamily="34" charset="-122"/>
                 <a:cs typeface="Trebuchet MS" pitchFamily="34" charset="-120"/>
               </a:rPr>
-              <a:t>We are learning that the prefix 'a-' means 'on, in, or into a state'.</a:t>
+              <a:t>We are learning that the prefix 'a-' means 'not, without, on, toward'.</a:t>
             </a:r>
             <a:endParaRPr lang="en-US" sz="2000" dirty="0"/>
           </a:p>
@@ -24338,7 +24439,7 @@
                 <a:ea typeface="Calibri" pitchFamily="34" charset="-122"/>
                 <a:cs typeface="Calibri" pitchFamily="34" charset="-120"/>
               </a:rPr>
-              <a:t>Word Labs  •  wordlabs.app  •  Prefix: 'a-' = on, in, or into a state</a:t>
+              <a:t>Word Labs  •  wordlabs.app  •  Prefix: 'a-' = not, without, on, toward</a:t>
             </a:r>
             <a:endParaRPr lang="en-US" sz="800" dirty="0"/>
           </a:p>
@@ -24477,7 +24578,7 @@
                 <a:ea typeface="Trebuchet MS" pitchFamily="34" charset="-122"/>
                 <a:cs typeface="Trebuchet MS" pitchFamily="34" charset="-120"/>
               </a:rPr>
-              <a:t>alive</a:t>
+              <a:t>ashore</a:t>
             </a:r>
             <a:endParaRPr lang="en-US" sz="2800" dirty="0"/>
           </a:p>
@@ -24655,7 +24756,7 @@
                 <a:ea typeface="Calibri" pitchFamily="34" charset="-122"/>
                 <a:cs typeface="Calibri" pitchFamily="34" charset="-120"/>
               </a:rPr>
-              <a:t>in a state of</a:t>
+              <a:t>on or toward</a:t>
             </a:r>
             <a:endParaRPr lang="en-US" sz="850" dirty="0"/>
           </a:p>
@@ -24728,7 +24829,7 @@
                 <a:ea typeface="Trebuchet MS" pitchFamily="34" charset="-122"/>
                 <a:cs typeface="Trebuchet MS" pitchFamily="34" charset="-120"/>
               </a:rPr>
-              <a:t>live</a:t>
+              <a:t>shore</a:t>
             </a:r>
             <a:endParaRPr lang="en-US" sz="1300" dirty="0"/>
           </a:p>
@@ -24767,7 +24868,7 @@
                 <a:ea typeface="Calibri" pitchFamily="34" charset="-122"/>
                 <a:cs typeface="Calibri" pitchFamily="34" charset="-120"/>
               </a:rPr>
-              <a:t>having life</a:t>
+              <a:t>the land at the edge of water</a:t>
             </a:r>
             <a:endParaRPr lang="en-US" sz="850" dirty="0"/>
           </a:p>
@@ -25031,7 +25132,7 @@
                 <a:ea typeface="Trebuchet MS" pitchFamily="34" charset="-122"/>
                 <a:cs typeface="Trebuchet MS" pitchFamily="34" charset="-120"/>
               </a:rPr>
-              <a:t>live</a:t>
+              <a:t>shore</a:t>
             </a:r>
             <a:endParaRPr lang="en-US" sz="1400" dirty="0"/>
           </a:p>
@@ -25455,7 +25556,7 @@
                 <a:ea typeface="Calibri" pitchFamily="34" charset="-122"/>
                 <a:cs typeface="Calibri" pitchFamily="34" charset="-120"/>
               </a:rPr>
-              <a:t>Word Labs  •  wordlabs.app  •  Prefix: 'a-' = on, in, or into a state</a:t>
+              <a:t>Word Labs  •  wordlabs.app  •  Prefix: 'a-' = not, without, on, toward</a:t>
             </a:r>
             <a:endParaRPr lang="en-US" sz="800" dirty="0"/>
           </a:p>
@@ -25594,7 +25695,7 @@
                 <a:ea typeface="Trebuchet MS" pitchFamily="34" charset="-122"/>
                 <a:cs typeface="Trebuchet MS" pitchFamily="34" charset="-120"/>
               </a:rPr>
-              <a:t>alive</a:t>
+              <a:t>ashore</a:t>
             </a:r>
             <a:endParaRPr lang="en-US" sz="2800" dirty="0"/>
           </a:p>
@@ -25772,7 +25873,7 @@
                 <a:ea typeface="Calibri" pitchFamily="34" charset="-122"/>
                 <a:cs typeface="Calibri" pitchFamily="34" charset="-120"/>
               </a:rPr>
-              <a:t>in a state of</a:t>
+              <a:t>on or toward</a:t>
             </a:r>
             <a:endParaRPr lang="en-US" sz="850" dirty="0"/>
           </a:p>
@@ -25845,7 +25946,7 @@
                 <a:ea typeface="Trebuchet MS" pitchFamily="34" charset="-122"/>
                 <a:cs typeface="Trebuchet MS" pitchFamily="34" charset="-120"/>
               </a:rPr>
-              <a:t>live</a:t>
+              <a:t>shore</a:t>
             </a:r>
             <a:endParaRPr lang="en-US" sz="1300" dirty="0"/>
           </a:p>
@@ -25884,7 +25985,7 @@
                 <a:ea typeface="Calibri" pitchFamily="34" charset="-122"/>
                 <a:cs typeface="Calibri" pitchFamily="34" charset="-120"/>
               </a:rPr>
-              <a:t>having life</a:t>
+              <a:t>the land at the edge of water</a:t>
             </a:r>
             <a:endParaRPr lang="en-US" sz="850" dirty="0"/>
           </a:p>
@@ -26148,7 +26249,7 @@
                 <a:ea typeface="Trebuchet MS" pitchFamily="34" charset="-122"/>
                 <a:cs typeface="Trebuchet MS" pitchFamily="34" charset="-120"/>
               </a:rPr>
-              <a:t>live</a:t>
+              <a:t>shore</a:t>
             </a:r>
             <a:endParaRPr lang="en-US" sz="1400" dirty="0"/>
           </a:p>
@@ -26229,11 +26330,11 @@
         <p:spPr>
           <a:xfrm>
             <a:off x="1874520" y="4096512"/>
-            <a:ext cx="6903720" cy="804672"/>
+            <a:ext cx="6903720" cy="658368"/>
           </a:xfrm>
           <a:prstGeom prst="rect">
             <a:avLst>
-              <a:gd name="adj" fmla="val 6818"/>
+              <a:gd name="adj" fmla="val 8333"/>
             </a:avLst>
           </a:prstGeom>
           <a:solidFill>
@@ -26256,11 +26357,11 @@
         <p:spPr>
           <a:xfrm>
             <a:off x="2670048" y="4169664"/>
-            <a:ext cx="685800" cy="384048"/>
+            <a:ext cx="685800" cy="475488"/>
           </a:xfrm>
           <a:prstGeom prst="rect">
             <a:avLst>
-              <a:gd name="adj" fmla="val 9524"/>
+              <a:gd name="adj" fmla="val 7692"/>
             </a:avLst>
           </a:prstGeom>
           <a:solidFill>
@@ -26283,7 +26384,7 @@
         <p:spPr>
           <a:xfrm>
             <a:off x="2670048" y="4169664"/>
-            <a:ext cx="685800" cy="384048"/>
+            <a:ext cx="685800" cy="475488"/>
           </a:xfrm>
           <a:prstGeom prst="rect">
             <a:avLst/>
@@ -26322,11 +26423,11 @@
         <p:spPr>
           <a:xfrm>
             <a:off x="4123944" y="4169664"/>
-            <a:ext cx="685800" cy="384048"/>
+            <a:ext cx="685800" cy="475488"/>
           </a:xfrm>
           <a:prstGeom prst="rect">
             <a:avLst>
-              <a:gd name="adj" fmla="val 9524"/>
+              <a:gd name="adj" fmla="val 7692"/>
             </a:avLst>
           </a:prstGeom>
           <a:solidFill>
@@ -26349,7 +26450,7 @@
         <p:spPr>
           <a:xfrm>
             <a:off x="4123944" y="4169664"/>
-            <a:ext cx="685800" cy="384048"/>
+            <a:ext cx="685800" cy="475488"/>
           </a:xfrm>
           <a:prstGeom prst="rect">
             <a:avLst/>
@@ -26373,7 +26474,7 @@
                 <a:ea typeface="Trebuchet MS" pitchFamily="34" charset="-122"/>
                 <a:cs typeface="Trebuchet MS" pitchFamily="34" charset="-120"/>
               </a:rPr>
-              <a:t>l</a:t>
+              <a:t>sh</a:t>
             </a:r>
             <a:endParaRPr lang="en-US" sz="900" dirty="0"/>
           </a:p>
@@ -26388,11 +26489,11 @@
         <p:spPr>
           <a:xfrm>
             <a:off x="5577840" y="4169664"/>
-            <a:ext cx="685800" cy="384048"/>
+            <a:ext cx="685800" cy="475488"/>
           </a:xfrm>
           <a:prstGeom prst="rect">
             <a:avLst>
-              <a:gd name="adj" fmla="val 9524"/>
+              <a:gd name="adj" fmla="val 7692"/>
             </a:avLst>
           </a:prstGeom>
           <a:solidFill>
@@ -26415,7 +26516,7 @@
         <p:spPr>
           <a:xfrm>
             <a:off x="5577840" y="4169664"/>
-            <a:ext cx="685800" cy="384048"/>
+            <a:ext cx="685800" cy="475488"/>
           </a:xfrm>
           <a:prstGeom prst="rect">
             <a:avLst/>
@@ -26439,7 +26540,7 @@
                 <a:ea typeface="Trebuchet MS" pitchFamily="34" charset="-122"/>
                 <a:cs typeface="Trebuchet MS" pitchFamily="34" charset="-120"/>
               </a:rPr>
-              <a:t>i</a:t>
+              <a:t>or</a:t>
             </a:r>
             <a:endParaRPr lang="en-US" sz="900" dirty="0"/>
           </a:p>
@@ -26454,11 +26555,11 @@
         <p:spPr>
           <a:xfrm>
             <a:off x="7031736" y="4169664"/>
-            <a:ext cx="685800" cy="384048"/>
+            <a:ext cx="685800" cy="475488"/>
           </a:xfrm>
           <a:prstGeom prst="rect">
             <a:avLst>
-              <a:gd name="adj" fmla="val 9524"/>
+              <a:gd name="adj" fmla="val 7692"/>
             </a:avLst>
           </a:prstGeom>
           <a:solidFill>
@@ -26481,7 +26582,7 @@
         <p:spPr>
           <a:xfrm>
             <a:off x="7031736" y="4169664"/>
-            <a:ext cx="685800" cy="384048"/>
+            <a:ext cx="685800" cy="475488"/>
           </a:xfrm>
           <a:prstGeom prst="rect">
             <a:avLst/>
@@ -26505,48 +26606,9 @@
                 <a:ea typeface="Trebuchet MS" pitchFamily="34" charset="-122"/>
                 <a:cs typeface="Trebuchet MS" pitchFamily="34" charset="-120"/>
               </a:rPr>
-              <a:t>ve</a:t>
+              <a:t>e</a:t>
             </a:r>
             <a:endParaRPr lang="en-US" sz="900" dirty="0"/>
-          </a:p>
-        </p:txBody>
-      </p:sp>
-      <p:sp>
-        <p:nvSpPr>
-          <p:cNvPr id="41" name="Text 39"/>
-          <p:cNvSpPr/>
-          <p:nvPr/>
-        </p:nvSpPr>
-        <p:spPr>
-          <a:xfrm>
-            <a:off x="7031736" y="4572000"/>
-            <a:ext cx="685800" cy="219456"/>
-          </a:xfrm>
-          <a:prstGeom prst="rect">
-            <a:avLst/>
-          </a:prstGeom>
-          <a:noFill/>
-          <a:ln/>
-        </p:spPr>
-        <p:txBody>
-          <a:bodyPr wrap="square" lIns="0" tIns="0" rIns="0" bIns="0" rtlCol="0" anchor="t"/>
-          <a:lstStyle/>
-          <a:p>
-            <a:pPr algn="ctr" indent="0" marL="0">
-              <a:buNone/>
-            </a:pPr>
-            <a:r>
-              <a:rPr lang="en-US" sz="750" i="1" dirty="0">
-                <a:solidFill>
-                  <a:srgbClr val="94A3B8"/>
-                </a:solidFill>
-                <a:latin typeface="Calibri" pitchFamily="34" charset="0"/>
-                <a:ea typeface="Calibri" pitchFamily="34" charset="-122"/>
-                <a:cs typeface="Calibri" pitchFamily="34" charset="-120"/>
-              </a:rPr>
-              <a:t>/v/</a:t>
-            </a:r>
-            <a:endParaRPr lang="en-US" sz="750" dirty="0"/>
           </a:p>
         </p:txBody>
       </p:sp>
@@ -26836,7 +26898,7 @@
                 <a:ea typeface="Calibri" pitchFamily="34" charset="-122"/>
                 <a:cs typeface="Calibri" pitchFamily="34" charset="-120"/>
               </a:rPr>
-              <a:t>Word Labs  •  wordlabs.app  •  Prefix: 'a-' = on, in, or into a state</a:t>
+              <a:t>Word Labs  •  wordlabs.app  •  Prefix: 'a-' = not, without, on, toward</a:t>
             </a:r>
             <a:endParaRPr lang="en-US" sz="800" dirty="0"/>
           </a:p>
@@ -26975,7 +27037,7 @@
                 <a:ea typeface="Trebuchet MS" pitchFamily="34" charset="-122"/>
                 <a:cs typeface="Trebuchet MS" pitchFamily="34" charset="-120"/>
               </a:rPr>
-              <a:t>aboard</a:t>
+              <a:t>afloat</a:t>
             </a:r>
             <a:endParaRPr lang="en-US" sz="2800" dirty="0"/>
           </a:p>
@@ -27663,7 +27725,7 @@
                 <a:ea typeface="Calibri" pitchFamily="34" charset="-122"/>
                 <a:cs typeface="Calibri" pitchFamily="34" charset="-120"/>
               </a:rPr>
-              <a:t>Word Labs  •  wordlabs.app  •  Prefix: 'a-' = on, in, or into a state</a:t>
+              <a:t>Word Labs  •  wordlabs.app  •  Prefix: 'a-' = not, without, on, toward</a:t>
             </a:r>
             <a:endParaRPr lang="en-US" sz="800" dirty="0"/>
           </a:p>
@@ -27802,7 +27864,7 @@
                 <a:ea typeface="Trebuchet MS" pitchFamily="34" charset="-122"/>
                 <a:cs typeface="Trebuchet MS" pitchFamily="34" charset="-120"/>
               </a:rPr>
-              <a:t>aboard</a:t>
+              <a:t>afloat</a:t>
             </a:r>
             <a:endParaRPr lang="en-US" sz="2800" dirty="0"/>
           </a:p>
@@ -27980,7 +28042,7 @@
                 <a:ea typeface="Calibri" pitchFamily="34" charset="-122"/>
                 <a:cs typeface="Calibri" pitchFamily="34" charset="-120"/>
               </a:rPr>
-              <a:t>on or into</a:t>
+              <a:t>in a state of</a:t>
             </a:r>
             <a:endParaRPr lang="en-US" sz="850" dirty="0"/>
           </a:p>
@@ -28053,7 +28115,7 @@
                 <a:ea typeface="Trebuchet MS" pitchFamily="34" charset="-122"/>
                 <a:cs typeface="Trebuchet MS" pitchFamily="34" charset="-120"/>
               </a:rPr>
-              <a:t>board</a:t>
+              <a:t>float</a:t>
             </a:r>
             <a:endParaRPr lang="en-US" sz="1300" dirty="0"/>
           </a:p>
@@ -28092,7 +28154,7 @@
                 <a:ea typeface="Calibri" pitchFamily="34" charset="-122"/>
                 <a:cs typeface="Calibri" pitchFamily="34" charset="-120"/>
               </a:rPr>
-              <a:t>a flat surface; a vessel</a:t>
+              <a:t>to rest on the surface of water</a:t>
             </a:r>
             <a:endParaRPr lang="en-US" sz="850" dirty="0"/>
           </a:p>
@@ -28648,7 +28710,7 @@
                 <a:ea typeface="Calibri" pitchFamily="34" charset="-122"/>
                 <a:cs typeface="Calibri" pitchFamily="34" charset="-120"/>
               </a:rPr>
-              <a:t>Word Labs  •  wordlabs.app  •  Prefix: 'a-' = on, in, or into a state</a:t>
+              <a:t>Word Labs  •  wordlabs.app  •  Prefix: 'a-' = not, without, on, toward</a:t>
             </a:r>
             <a:endParaRPr lang="en-US" sz="800" dirty="0"/>
           </a:p>
@@ -28787,7 +28849,7 @@
                 <a:ea typeface="Trebuchet MS" pitchFamily="34" charset="-122"/>
                 <a:cs typeface="Trebuchet MS" pitchFamily="34" charset="-120"/>
               </a:rPr>
-              <a:t>aboard</a:t>
+              <a:t>afloat</a:t>
             </a:r>
             <a:endParaRPr lang="en-US" sz="2800" dirty="0"/>
           </a:p>
@@ -28965,7 +29027,7 @@
                 <a:ea typeface="Calibri" pitchFamily="34" charset="-122"/>
                 <a:cs typeface="Calibri" pitchFamily="34" charset="-120"/>
               </a:rPr>
-              <a:t>on or into</a:t>
+              <a:t>in a state of</a:t>
             </a:r>
             <a:endParaRPr lang="en-US" sz="850" dirty="0"/>
           </a:p>
@@ -29038,7 +29100,7 @@
                 <a:ea typeface="Trebuchet MS" pitchFamily="34" charset="-122"/>
                 <a:cs typeface="Trebuchet MS" pitchFamily="34" charset="-120"/>
               </a:rPr>
-              <a:t>board</a:t>
+              <a:t>float</a:t>
             </a:r>
             <a:endParaRPr lang="en-US" sz="1300" dirty="0"/>
           </a:p>
@@ -29077,7 +29139,7 @@
                 <a:ea typeface="Calibri" pitchFamily="34" charset="-122"/>
                 <a:cs typeface="Calibri" pitchFamily="34" charset="-120"/>
               </a:rPr>
-              <a:t>a flat surface; a vessel</a:t>
+              <a:t>to rest on the surface of water</a:t>
             </a:r>
             <a:endParaRPr lang="en-US" sz="850" dirty="0"/>
           </a:p>
@@ -29341,7 +29403,7 @@
                 <a:ea typeface="Trebuchet MS" pitchFamily="34" charset="-122"/>
                 <a:cs typeface="Trebuchet MS" pitchFamily="34" charset="-120"/>
               </a:rPr>
-              <a:t>board</a:t>
+              <a:t>float</a:t>
             </a:r>
             <a:endParaRPr lang="en-US" sz="1400" dirty="0"/>
           </a:p>
@@ -29765,7 +29827,7 @@
                 <a:ea typeface="Calibri" pitchFamily="34" charset="-122"/>
                 <a:cs typeface="Calibri" pitchFamily="34" charset="-120"/>
               </a:rPr>
-              <a:t>Word Labs  •  wordlabs.app  •  Prefix: 'a-' = on, in, or into a state</a:t>
+              <a:t>Word Labs  •  wordlabs.app  •  Prefix: 'a-' = not, without, on, toward</a:t>
             </a:r>
             <a:endParaRPr lang="en-US" sz="800" dirty="0"/>
           </a:p>
@@ -29904,7 +29966,7 @@
                 <a:ea typeface="Trebuchet MS" pitchFamily="34" charset="-122"/>
                 <a:cs typeface="Trebuchet MS" pitchFamily="34" charset="-120"/>
               </a:rPr>
-              <a:t>aboard</a:t>
+              <a:t>afloat</a:t>
             </a:r>
             <a:endParaRPr lang="en-US" sz="2800" dirty="0"/>
           </a:p>
@@ -30082,7 +30144,7 @@
                 <a:ea typeface="Calibri" pitchFamily="34" charset="-122"/>
                 <a:cs typeface="Calibri" pitchFamily="34" charset="-120"/>
               </a:rPr>
-              <a:t>on or into</a:t>
+              <a:t>in a state of</a:t>
             </a:r>
             <a:endParaRPr lang="en-US" sz="850" dirty="0"/>
           </a:p>
@@ -30155,7 +30217,7 @@
                 <a:ea typeface="Trebuchet MS" pitchFamily="34" charset="-122"/>
                 <a:cs typeface="Trebuchet MS" pitchFamily="34" charset="-120"/>
               </a:rPr>
-              <a:t>board</a:t>
+              <a:t>float</a:t>
             </a:r>
             <a:endParaRPr lang="en-US" sz="1300" dirty="0"/>
           </a:p>
@@ -30194,7 +30256,7 @@
                 <a:ea typeface="Calibri" pitchFamily="34" charset="-122"/>
                 <a:cs typeface="Calibri" pitchFamily="34" charset="-120"/>
               </a:rPr>
-              <a:t>a flat surface; a vessel</a:t>
+              <a:t>to rest on the surface of water</a:t>
             </a:r>
             <a:endParaRPr lang="en-US" sz="850" dirty="0"/>
           </a:p>
@@ -30458,7 +30520,7 @@
                 <a:ea typeface="Trebuchet MS" pitchFamily="34" charset="-122"/>
                 <a:cs typeface="Trebuchet MS" pitchFamily="34" charset="-120"/>
               </a:rPr>
-              <a:t>board</a:t>
+              <a:t>float</a:t>
             </a:r>
             <a:endParaRPr lang="en-US" sz="1400" dirty="0"/>
           </a:p>
@@ -30565,7 +30627,7 @@
         </p:nvSpPr>
         <p:spPr>
           <a:xfrm>
-            <a:off x="2670048" y="4169664"/>
+            <a:off x="2427732" y="4169664"/>
             <a:ext cx="685800" cy="475488"/>
           </a:xfrm>
           <a:prstGeom prst="rect">
@@ -30592,7 +30654,7 @@
         </p:nvSpPr>
         <p:spPr>
           <a:xfrm>
-            <a:off x="2670048" y="4169664"/>
+            <a:off x="2427732" y="4169664"/>
             <a:ext cx="685800" cy="475488"/>
           </a:xfrm>
           <a:prstGeom prst="rect">
@@ -30631,7 +30693,7 @@
         </p:nvSpPr>
         <p:spPr>
           <a:xfrm>
-            <a:off x="4123944" y="4169664"/>
+            <a:off x="3639312" y="4169664"/>
             <a:ext cx="685800" cy="475488"/>
           </a:xfrm>
           <a:prstGeom prst="rect">
@@ -30658,7 +30720,7 @@
         </p:nvSpPr>
         <p:spPr>
           <a:xfrm>
-            <a:off x="4123944" y="4169664"/>
+            <a:off x="3639312" y="4169664"/>
             <a:ext cx="685800" cy="475488"/>
           </a:xfrm>
           <a:prstGeom prst="rect">
@@ -30683,7 +30745,7 @@
                 <a:ea typeface="Trebuchet MS" pitchFamily="34" charset="-122"/>
                 <a:cs typeface="Trebuchet MS" pitchFamily="34" charset="-120"/>
               </a:rPr>
-              <a:t>b</a:t>
+              <a:t>f</a:t>
             </a:r>
             <a:endParaRPr lang="en-US" sz="900" dirty="0"/>
           </a:p>
@@ -30697,7 +30759,7 @@
         </p:nvSpPr>
         <p:spPr>
           <a:xfrm>
-            <a:off x="5577840" y="4169664"/>
+            <a:off x="4850892" y="4169664"/>
             <a:ext cx="685800" cy="475488"/>
           </a:xfrm>
           <a:prstGeom prst="rect">
@@ -30724,7 +30786,7 @@
         </p:nvSpPr>
         <p:spPr>
           <a:xfrm>
-            <a:off x="5577840" y="4169664"/>
+            <a:off x="4850892" y="4169664"/>
             <a:ext cx="685800" cy="475488"/>
           </a:xfrm>
           <a:prstGeom prst="rect">
@@ -30749,7 +30811,7 @@
                 <a:ea typeface="Trebuchet MS" pitchFamily="34" charset="-122"/>
                 <a:cs typeface="Trebuchet MS" pitchFamily="34" charset="-120"/>
               </a:rPr>
-              <a:t>oar</a:t>
+              <a:t>l</a:t>
             </a:r>
             <a:endParaRPr lang="en-US" sz="900" dirty="0"/>
           </a:p>
@@ -30763,7 +30825,7 @@
         </p:nvSpPr>
         <p:spPr>
           <a:xfrm>
-            <a:off x="7031736" y="4169664"/>
+            <a:off x="6062472" y="4169664"/>
             <a:ext cx="685800" cy="475488"/>
           </a:xfrm>
           <a:prstGeom prst="rect">
@@ -30790,7 +30852,7 @@
         </p:nvSpPr>
         <p:spPr>
           <a:xfrm>
-            <a:off x="7031736" y="4169664"/>
+            <a:off x="6062472" y="4169664"/>
             <a:ext cx="685800" cy="475488"/>
           </a:xfrm>
           <a:prstGeom prst="rect">
@@ -30815,7 +30877,73 @@
                 <a:ea typeface="Trebuchet MS" pitchFamily="34" charset="-122"/>
                 <a:cs typeface="Trebuchet MS" pitchFamily="34" charset="-120"/>
               </a:rPr>
-              <a:t>d</a:t>
+              <a:t>oa</a:t>
+            </a:r>
+            <a:endParaRPr lang="en-US" sz="900" dirty="0"/>
+          </a:p>
+        </p:txBody>
+      </p:sp>
+      <p:sp>
+        <p:nvSpPr>
+          <p:cNvPr id="41" name="Shape 39"/>
+          <p:cNvSpPr/>
+          <p:nvPr/>
+        </p:nvSpPr>
+        <p:spPr>
+          <a:xfrm>
+            <a:off x="7274052" y="4169664"/>
+            <a:ext cx="685800" cy="475488"/>
+          </a:xfrm>
+          <a:prstGeom prst="rect">
+            <a:avLst>
+              <a:gd name="adj" fmla="val 7692"/>
+            </a:avLst>
+          </a:prstGeom>
+          <a:solidFill>
+            <a:srgbClr val="FFFFFF"/>
+          </a:solidFill>
+          <a:ln w="12700">
+            <a:solidFill>
+              <a:srgbClr val="DB2777"/>
+            </a:solidFill>
+            <a:prstDash val="solid"/>
+          </a:ln>
+        </p:spPr>
+      </p:sp>
+      <p:sp>
+        <p:nvSpPr>
+          <p:cNvPr id="42" name="Text 40"/>
+          <p:cNvSpPr/>
+          <p:nvPr/>
+        </p:nvSpPr>
+        <p:spPr>
+          <a:xfrm>
+            <a:off x="7274052" y="4169664"/>
+            <a:ext cx="685800" cy="475488"/>
+          </a:xfrm>
+          <a:prstGeom prst="rect">
+            <a:avLst/>
+          </a:prstGeom>
+          <a:noFill/>
+          <a:ln/>
+        </p:spPr>
+        <p:txBody>
+          <a:bodyPr wrap="square" lIns="0" tIns="0" rIns="0" bIns="0" rtlCol="0" anchor="ctr"/>
+          <a:lstStyle/>
+          <a:p>
+            <a:pPr algn="ctr" indent="0" marL="0">
+              <a:buNone/>
+            </a:pPr>
+            <a:r>
+              <a:rPr lang="en-US" sz="900" b="1" dirty="0">
+                <a:solidFill>
+                  <a:srgbClr val="9D174D"/>
+                </a:solidFill>
+                <a:latin typeface="Trebuchet MS" pitchFamily="34" charset="0"/>
+                <a:ea typeface="Trebuchet MS" pitchFamily="34" charset="-122"/>
+                <a:cs typeface="Trebuchet MS" pitchFamily="34" charset="-120"/>
+              </a:rPr>
+              <a:t>t</a:t>
             </a:r>
             <a:endParaRPr lang="en-US" sz="900" dirty="0"/>
           </a:p>
@@ -31107,7 +31235,7 @@
                 <a:ea typeface="Calibri" pitchFamily="34" charset="-122"/>
                 <a:cs typeface="Calibri" pitchFamily="34" charset="-120"/>
               </a:rPr>
-              <a:t>Word Labs  •  wordlabs.app  •  Prefix: 'a-' = on, in, or into a state</a:t>
+              <a:t>Word Labs  •  wordlabs.app  •  Prefix: 'a-' = not, without, on, toward</a:t>
             </a:r>
             <a:endParaRPr lang="en-US" sz="800" dirty="0"/>
           </a:p>
@@ -32276,7 +32404,7 @@
                 <a:ea typeface="Calibri" pitchFamily="34" charset="-122"/>
                 <a:cs typeface="Calibri" pitchFamily="34" charset="-120"/>
               </a:rPr>
-              <a:t>Word Labs  •  wordlabs.app  •  Prefix: 'a-' = on, in, or into a state</a:t>
+              <a:t>Word Labs  •  wordlabs.app  •  Prefix: 'a-' = not, without, on, toward</a:t>
             </a:r>
             <a:endParaRPr lang="en-US" sz="800" dirty="0"/>
           </a:p>
@@ -32641,7 +32769,7 @@
                 <a:ea typeface="Trebuchet MS" pitchFamily="34" charset="-122"/>
                 <a:cs typeface="Trebuchet MS" pitchFamily="34" charset="-120"/>
               </a:rPr>
-              <a:t>wake</a:t>
+              <a:t>way</a:t>
             </a:r>
             <a:endParaRPr lang="en-US" sz="1300" dirty="0"/>
           </a:p>
@@ -32794,7 +32922,7 @@
                 <a:ea typeface="Trebuchet MS" pitchFamily="34" charset="-122"/>
                 <a:cs typeface="Trebuchet MS" pitchFamily="34" charset="-120"/>
               </a:rPr>
-              <a:t>live</a:t>
+              <a:t>board</a:t>
             </a:r>
             <a:endParaRPr lang="en-US" sz="1300" dirty="0"/>
           </a:p>
@@ -32947,7 +33075,7 @@
                 <a:ea typeface="Trebuchet MS" pitchFamily="34" charset="-122"/>
                 <a:cs typeface="Trebuchet MS" pitchFamily="34" charset="-120"/>
               </a:rPr>
-              <a:t>like</a:t>
+              <a:t>wake</a:t>
             </a:r>
             <a:endParaRPr lang="en-US" sz="1300" dirty="0"/>
           </a:p>
@@ -33100,7 +33228,7 @@
                 <a:ea typeface="Trebuchet MS" pitchFamily="34" charset="-122"/>
                 <a:cs typeface="Trebuchet MS" pitchFamily="34" charset="-120"/>
               </a:rPr>
-              <a:t>board</a:t>
+              <a:t>live</a:t>
             </a:r>
             <a:endParaRPr lang="en-US" sz="1300" dirty="0"/>
           </a:p>
@@ -33253,7 +33381,7 @@
                 <a:ea typeface="Trebuchet MS" pitchFamily="34" charset="-122"/>
                 <a:cs typeface="Trebuchet MS" pitchFamily="34" charset="-120"/>
               </a:rPr>
-              <a:t>sleep</a:t>
+              <a:t>lone</a:t>
             </a:r>
             <a:endParaRPr lang="en-US" sz="1300" dirty="0"/>
           </a:p>
@@ -33317,7 +33445,7 @@
                 <a:ea typeface="Trebuchet MS" pitchFamily="34" charset="-122"/>
                 <a:cs typeface="Trebuchet MS" pitchFamily="34" charset="-120"/>
               </a:rPr>
-              <a:t>-en</a:t>
+              <a:t>-ment</a:t>
             </a:r>
             <a:endParaRPr lang="en-US" sz="1300" dirty="0"/>
           </a:p>
@@ -33488,7 +33616,7 @@
                 <a:ea typeface="Trebuchet MS" pitchFamily="34" charset="-122"/>
                 <a:cs typeface="Trebuchet MS" pitchFamily="34" charset="-120"/>
               </a:rPr>
-              <a:t>alive</a:t>
+              <a:t>ashore</a:t>
             </a:r>
             <a:endParaRPr lang="en-US" sz="1200" dirty="0"/>
           </a:p>
@@ -33620,7 +33748,7 @@
                 <a:ea typeface="Trebuchet MS" pitchFamily="34" charset="-122"/>
                 <a:cs typeface="Trebuchet MS" pitchFamily="34" charset="-120"/>
               </a:rPr>
-              <a:t>ashore</a:t>
+              <a:t>aloft</a:t>
             </a:r>
             <a:endParaRPr lang="en-US" sz="1200" dirty="0"/>
           </a:p>
@@ -33686,7 +33814,7 @@
                 <a:ea typeface="Trebuchet MS" pitchFamily="34" charset="-122"/>
                 <a:cs typeface="Trebuchet MS" pitchFamily="34" charset="-120"/>
               </a:rPr>
-              <a:t>aside</a:t>
+              <a:t>astray</a:t>
             </a:r>
             <a:endParaRPr lang="en-US" sz="1200" dirty="0"/>
           </a:p>
@@ -33752,7 +33880,7 @@
                 <a:ea typeface="Trebuchet MS" pitchFamily="34" charset="-122"/>
                 <a:cs typeface="Trebuchet MS" pitchFamily="34" charset="-120"/>
               </a:rPr>
-              <a:t>aloud</a:t>
+              <a:t>afoot</a:t>
             </a:r>
             <a:endParaRPr lang="en-US" sz="1200" dirty="0"/>
           </a:p>
@@ -33818,7 +33946,7 @@
                 <a:ea typeface="Trebuchet MS" pitchFamily="34" charset="-122"/>
                 <a:cs typeface="Trebuchet MS" pitchFamily="34" charset="-120"/>
               </a:rPr>
-              <a:t>afloat</a:t>
+              <a:t>ablaze</a:t>
             </a:r>
             <a:endParaRPr lang="en-US" sz="1200" dirty="0"/>
           </a:p>
@@ -33884,7 +34012,7 @@
                 <a:ea typeface="Trebuchet MS" pitchFamily="34" charset="-122"/>
                 <a:cs typeface="Trebuchet MS" pitchFamily="34" charset="-120"/>
               </a:rPr>
-              <a:t>alight</a:t>
+              <a:t>afloat</a:t>
             </a:r>
             <a:endParaRPr lang="en-US" sz="1200" dirty="0"/>
           </a:p>
@@ -34176,7 +34304,7 @@
                 <a:ea typeface="Calibri" pitchFamily="34" charset="-122"/>
                 <a:cs typeface="Calibri" pitchFamily="34" charset="-120"/>
               </a:rPr>
-              <a:t>Word Labs  •  wordlabs.app  •  Prefix: 'a-' = on, in, or into a state</a:t>
+              <a:t>Word Labs  •  wordlabs.app  •  Prefix: 'a-' = not, without, on, toward</a:t>
             </a:r>
             <a:endParaRPr lang="en-US" sz="800" dirty="0"/>
           </a:p>
@@ -34340,7 +34468,7 @@
                 <a:ea typeface="Calibri" pitchFamily="34" charset="-122"/>
                 <a:cs typeface="Calibri" pitchFamily="34" charset="-120"/>
               </a:rPr>
-              <a:t>A meaningful word part added to the beginning of a root to change its meaning. The prefix 'a-' means 'on, in, or into a state'.</a:t>
+              <a:t>A meaningful word part added to the beginning of a root to change its meaning. The prefix 'a-' means 'not, without, on, toward'.</a:t>
             </a:r>
             <a:endParaRPr lang="en-US" sz="1350" dirty="0"/>
           </a:p>
@@ -34960,7 +35088,7 @@
                 <a:ea typeface="Calibri" pitchFamily="34" charset="-122"/>
                 <a:cs typeface="Calibri" pitchFamily="34" charset="-120"/>
               </a:rPr>
-              <a:t>Word Labs  •  wordlabs.app  •  Prefix: 'a-' = on, in, or into a state</a:t>
+              <a:t>Word Labs  •  wordlabs.app  •  Prefix: 'a-' = not, without, on, toward</a:t>
             </a:r>
             <a:endParaRPr lang="en-US" sz="800" dirty="0"/>
           </a:p>
@@ -35072,7 +35200,7 @@
                 <a:ea typeface="Calibri" pitchFamily="34" charset="-122"/>
                 <a:cs typeface="Calibri" pitchFamily="34" charset="-120"/>
               </a:rPr>
-              <a:t>1.  The prefix 'a-' can mean 'on' or 'in a state of', as in 'asleep' meaning in a state of sleep.</a:t>
+              <a:t>1.  The prefix 'a-' always makes a word mean the opposite of its base word.</a:t>
             </a:r>
             <a:endParaRPr lang="en-US" sz="1300" dirty="0"/>
           </a:p>
@@ -35095,11 +35223,11 @@
             </a:avLst>
           </a:prstGeom>
           <a:solidFill>
-            <a:srgbClr val="DCFCE7"/>
-          </a:solidFill>
-          <a:ln w="12700">
-            <a:solidFill>
-              <a:srgbClr val="16A34A"/>
+            <a:srgbClr val="FEE2E2"/>
+          </a:solidFill>
+          <a:ln w="12700">
+            <a:solidFill>
+              <a:srgbClr val="DC2626"/>
             </a:solidFill>
             <a:prstDash val="solid"/>
           </a:ln>
@@ -35132,13 +35260,13 @@
             <a:r>
               <a:rPr lang="en-US" sz="1100" b="1" dirty="0">
                 <a:solidFill>
-                  <a:srgbClr val="16A34A"/>
+                  <a:srgbClr val="DC2626"/>
                 </a:solidFill>
                 <a:latin typeface="Trebuchet MS" pitchFamily="34" charset="0"/>
                 <a:ea typeface="Trebuchet MS" pitchFamily="34" charset="-122"/>
                 <a:cs typeface="Trebuchet MS" pitchFamily="34" charset="-120"/>
               </a:rPr>
-              <a:t>TRUE</a:t>
+              <a:t>FALSE</a:t>
             </a:r>
             <a:endParaRPr lang="en-US" sz="1100" dirty="0"/>
           </a:p>
@@ -35211,7 +35339,7 @@
                 <a:ea typeface="Calibri" pitchFamily="34" charset="-122"/>
                 <a:cs typeface="Calibri" pitchFamily="34" charset="-120"/>
               </a:rPr>
-              <a:t>2.  The prefix 'a-' always makes a word mean the opposite of the base word.</a:t>
+              <a:t>2.  The word 'aboard' uses the prefix 'a-' to mean 'on board'.</a:t>
             </a:r>
             <a:endParaRPr lang="en-US" sz="1300" dirty="0"/>
           </a:p>
@@ -35234,11 +35362,11 @@
             </a:avLst>
           </a:prstGeom>
           <a:solidFill>
-            <a:srgbClr val="FEE2E2"/>
-          </a:solidFill>
-          <a:ln w="12700">
-            <a:solidFill>
-              <a:srgbClr val="DC2626"/>
+            <a:srgbClr val="DCFCE7"/>
+          </a:solidFill>
+          <a:ln w="12700">
+            <a:solidFill>
+              <a:srgbClr val="16A34A"/>
             </a:solidFill>
             <a:prstDash val="solid"/>
           </a:ln>
@@ -35271,13 +35399,13 @@
             <a:r>
               <a:rPr lang="en-US" sz="1100" b="1" dirty="0">
                 <a:solidFill>
-                  <a:srgbClr val="DC2626"/>
+                  <a:srgbClr val="16A34A"/>
                 </a:solidFill>
                 <a:latin typeface="Trebuchet MS" pitchFamily="34" charset="0"/>
                 <a:ea typeface="Trebuchet MS" pitchFamily="34" charset="-122"/>
                 <a:cs typeface="Trebuchet MS" pitchFamily="34" charset="-120"/>
               </a:rPr>
-              <a:t>FALSE</a:t>
+              <a:t>TRUE</a:t>
             </a:r>
             <a:endParaRPr lang="en-US" sz="1100" dirty="0"/>
           </a:p>
@@ -35350,7 +35478,7 @@
                 <a:ea typeface="Calibri" pitchFamily="34" charset="-122"/>
                 <a:cs typeface="Calibri" pitchFamily="34" charset="-120"/>
               </a:rPr>
-              <a:t>3.  The word 'aboard' uses the prefix 'a-' meaning 'on', so aboard means on board.</a:t>
+              <a:t>3.  The prefix 'a-' can mean 'on' or 'in a state of', as in 'asleep' or 'ablaze'.</a:t>
             </a:r>
             <a:endParaRPr lang="en-US" sz="1300" dirty="0"/>
           </a:p>
@@ -35489,7 +35617,7 @@
                 <a:ea typeface="Calibri" pitchFamily="34" charset="-122"/>
                 <a:cs typeface="Calibri" pitchFamily="34" charset="-120"/>
               </a:rPr>
-              <a:t>4.  The prefix 'a-' comes from Old English.</a:t>
+              <a:t>4.  The prefix 'a-' comes only from Latin and has no Greek or Old English origins.</a:t>
             </a:r>
             <a:endParaRPr lang="en-US" sz="1300" dirty="0"/>
           </a:p>
@@ -35512,11 +35640,11 @@
             </a:avLst>
           </a:prstGeom>
           <a:solidFill>
-            <a:srgbClr val="DCFCE7"/>
-          </a:solidFill>
-          <a:ln w="12700">
-            <a:solidFill>
-              <a:srgbClr val="16A34A"/>
+            <a:srgbClr val="FEE2E2"/>
+          </a:solidFill>
+          <a:ln w="12700">
+            <a:solidFill>
+              <a:srgbClr val="DC2626"/>
             </a:solidFill>
             <a:prstDash val="solid"/>
           </a:ln>
@@ -35549,13 +35677,13 @@
             <a:r>
               <a:rPr lang="en-US" sz="1100" b="1" dirty="0">
                 <a:solidFill>
-                  <a:srgbClr val="16A34A"/>
+                  <a:srgbClr val="DC2626"/>
                 </a:solidFill>
                 <a:latin typeface="Trebuchet MS" pitchFamily="34" charset="0"/>
                 <a:ea typeface="Trebuchet MS" pitchFamily="34" charset="-122"/>
                 <a:cs typeface="Trebuchet MS" pitchFamily="34" charset="-120"/>
               </a:rPr>
-              <a:t>TRUE</a:t>
+              <a:t>FALSE</a:t>
             </a:r>
             <a:endParaRPr lang="en-US" sz="1100" dirty="0"/>
           </a:p>
@@ -35628,7 +35756,7 @@
                 <a:ea typeface="Calibri" pitchFamily="34" charset="-122"/>
                 <a:cs typeface="Calibri" pitchFamily="34" charset="-120"/>
               </a:rPr>
-              <a:t>5.  Every word that starts with the letter 'a' uses the prefix 'a-'.</a:t>
+              <a:t>5.  The word 'awake' uses the prefix 'a-' combined with the base word 'wake'.</a:t>
             </a:r>
             <a:endParaRPr lang="en-US" sz="1300" dirty="0"/>
           </a:p>
@@ -35651,11 +35779,11 @@
             </a:avLst>
           </a:prstGeom>
           <a:solidFill>
-            <a:srgbClr val="FEE2E2"/>
-          </a:solidFill>
-          <a:ln w="12700">
-            <a:solidFill>
-              <a:srgbClr val="DC2626"/>
+            <a:srgbClr val="DCFCE7"/>
+          </a:solidFill>
+          <a:ln w="12700">
+            <a:solidFill>
+              <a:srgbClr val="16A34A"/>
             </a:solidFill>
             <a:prstDash val="solid"/>
           </a:ln>
@@ -35688,13 +35816,13 @@
             <a:r>
               <a:rPr lang="en-US" sz="1100" b="1" dirty="0">
                 <a:solidFill>
-                  <a:srgbClr val="DC2626"/>
+                  <a:srgbClr val="16A34A"/>
                 </a:solidFill>
                 <a:latin typeface="Trebuchet MS" pitchFamily="34" charset="0"/>
                 <a:ea typeface="Trebuchet MS" pitchFamily="34" charset="-122"/>
                 <a:cs typeface="Trebuchet MS" pitchFamily="34" charset="-120"/>
               </a:rPr>
-              <a:t>FALSE</a:t>
+              <a:t>TRUE</a:t>
             </a:r>
             <a:endParaRPr lang="en-US" sz="1100" dirty="0"/>
           </a:p>
@@ -35986,7 +36114,7 @@
                 <a:ea typeface="Calibri" pitchFamily="34" charset="-122"/>
                 <a:cs typeface="Calibri" pitchFamily="34" charset="-120"/>
               </a:rPr>
-              <a:t>Word Labs  •  wordlabs.app  •  Prefix: 'a-' = on, in, or into a state</a:t>
+              <a:t>Word Labs  •  wordlabs.app  •  Prefix: 'a-' = not, without, on, toward</a:t>
             </a:r>
             <a:endParaRPr lang="en-US" sz="800" dirty="0"/>
           </a:p>
@@ -36123,7 +36251,7 @@
                 <a:ea typeface="Trebuchet MS" pitchFamily="34" charset="-122"/>
                 <a:cs typeface="Trebuchet MS" pitchFamily="34" charset="-120"/>
               </a:rPr>
-              <a:t>on, in, or into a state</a:t>
+              <a:t>not, without, on, toward</a:t>
             </a:r>
             <a:endParaRPr lang="en-US" sz="2000" dirty="0"/>
           </a:p>
@@ -36162,7 +36290,7 @@
                 <a:ea typeface="Calibri" pitchFamily="34" charset="-122"/>
                 <a:cs typeface="Calibri" pitchFamily="34" charset="-120"/>
               </a:rPr>
-              <a:t>Origin: Old English: on</a:t>
+              <a:t>Origin: Greek: a- / Latin: ad- / Old English: on-</a:t>
             </a:r>
             <a:endParaRPr lang="en-US" sz="1100" dirty="0"/>
           </a:p>
@@ -36333,7 +36461,7 @@
                 <a:ea typeface="Trebuchet MS" pitchFamily="34" charset="-122"/>
                 <a:cs typeface="Trebuchet MS" pitchFamily="34" charset="-120"/>
               </a:rPr>
-              <a:t>alive</a:t>
+              <a:t>ashore</a:t>
             </a:r>
             <a:endParaRPr lang="en-US" sz="1300" dirty="0"/>
           </a:p>
@@ -36465,7 +36593,7 @@
                 <a:ea typeface="Trebuchet MS" pitchFamily="34" charset="-122"/>
                 <a:cs typeface="Trebuchet MS" pitchFamily="34" charset="-120"/>
               </a:rPr>
-              <a:t>ashore</a:t>
+              <a:t>aloft</a:t>
             </a:r>
             <a:endParaRPr lang="en-US" sz="1300" dirty="0"/>
           </a:p>
@@ -36531,7 +36659,7 @@
                 <a:ea typeface="Trebuchet MS" pitchFamily="34" charset="-122"/>
                 <a:cs typeface="Trebuchet MS" pitchFamily="34" charset="-120"/>
               </a:rPr>
-              <a:t>aside</a:t>
+              <a:t>astray</a:t>
             </a:r>
             <a:endParaRPr lang="en-US" sz="1300" dirty="0"/>
           </a:p>
@@ -36597,7 +36725,7 @@
                 <a:ea typeface="Trebuchet MS" pitchFamily="34" charset="-122"/>
                 <a:cs typeface="Trebuchet MS" pitchFamily="34" charset="-120"/>
               </a:rPr>
-              <a:t>aloud</a:t>
+              <a:t>afoot</a:t>
             </a:r>
             <a:endParaRPr lang="en-US" sz="1300" dirty="0"/>
           </a:p>
@@ -36663,7 +36791,7 @@
                 <a:ea typeface="Trebuchet MS" pitchFamily="34" charset="-122"/>
                 <a:cs typeface="Trebuchet MS" pitchFamily="34" charset="-120"/>
               </a:rPr>
-              <a:t>afloat</a:t>
+              <a:t>ablaze</a:t>
             </a:r>
             <a:endParaRPr lang="en-US" sz="1300" dirty="0"/>
           </a:p>
@@ -36955,7 +37083,7 @@
                 <a:ea typeface="Calibri" pitchFamily="34" charset="-122"/>
                 <a:cs typeface="Calibri" pitchFamily="34" charset="-120"/>
               </a:rPr>
-              <a:t>Word Labs  •  wordlabs.app  •  Prefix: 'a-' = on, in, or into a state</a:t>
+              <a:t>Word Labs  •  wordlabs.app  •  Prefix: 'a-' = not, without, on, toward</a:t>
             </a:r>
             <a:endParaRPr lang="en-US" sz="800" dirty="0"/>
           </a:p>
@@ -37320,7 +37448,7 @@
                 <a:ea typeface="Trebuchet MS" pitchFamily="34" charset="-122"/>
                 <a:cs typeface="Trebuchet MS" pitchFamily="34" charset="-120"/>
               </a:rPr>
-              <a:t>wake</a:t>
+              <a:t>way</a:t>
             </a:r>
             <a:endParaRPr lang="en-US" sz="1300" dirty="0"/>
           </a:p>
@@ -37473,7 +37601,7 @@
                 <a:ea typeface="Trebuchet MS" pitchFamily="34" charset="-122"/>
                 <a:cs typeface="Trebuchet MS" pitchFamily="34" charset="-120"/>
               </a:rPr>
-              <a:t>live</a:t>
+              <a:t>board</a:t>
             </a:r>
             <a:endParaRPr lang="en-US" sz="1300" dirty="0"/>
           </a:p>
@@ -37626,7 +37754,7 @@
                 <a:ea typeface="Trebuchet MS" pitchFamily="34" charset="-122"/>
                 <a:cs typeface="Trebuchet MS" pitchFamily="34" charset="-120"/>
               </a:rPr>
-              <a:t>like</a:t>
+              <a:t>wake</a:t>
             </a:r>
             <a:endParaRPr lang="en-US" sz="1300" dirty="0"/>
           </a:p>
@@ -37779,7 +37907,7 @@
                 <a:ea typeface="Trebuchet MS" pitchFamily="34" charset="-122"/>
                 <a:cs typeface="Trebuchet MS" pitchFamily="34" charset="-120"/>
               </a:rPr>
-              <a:t>board</a:t>
+              <a:t>live</a:t>
             </a:r>
             <a:endParaRPr lang="en-US" sz="1300" dirty="0"/>
           </a:p>
@@ -37932,7 +38060,7 @@
                 <a:ea typeface="Trebuchet MS" pitchFamily="34" charset="-122"/>
                 <a:cs typeface="Trebuchet MS" pitchFamily="34" charset="-120"/>
               </a:rPr>
-              <a:t>sleep</a:t>
+              <a:t>lone</a:t>
             </a:r>
             <a:endParaRPr lang="en-US" sz="1300" dirty="0"/>
           </a:p>
@@ -37996,7 +38124,7 @@
                 <a:ea typeface="Trebuchet MS" pitchFamily="34" charset="-122"/>
                 <a:cs typeface="Trebuchet MS" pitchFamily="34" charset="-120"/>
               </a:rPr>
-              <a:t>-en</a:t>
+              <a:t>-ment</a:t>
             </a:r>
             <a:endParaRPr lang="en-US" sz="1300" dirty="0"/>
           </a:p>
@@ -38162,7 +38290,7 @@
         <p:spPr>
           <a:xfrm>
             <a:off x="2706624" y="4178808"/>
-            <a:ext cx="950976" cy="420624"/>
+            <a:ext cx="822960" cy="420624"/>
           </a:xfrm>
           <a:prstGeom prst="rect">
             <a:avLst>
@@ -38196,7 +38324,7 @@
         <p:spPr>
           <a:xfrm>
             <a:off x="2706624" y="4178808"/>
-            <a:ext cx="950976" cy="420624"/>
+            <a:ext cx="822960" cy="420624"/>
           </a:xfrm>
           <a:prstGeom prst="rect">
             <a:avLst/>
@@ -38220,7 +38348,7 @@
                 <a:ea typeface="Trebuchet MS" pitchFamily="34" charset="-122"/>
                 <a:cs typeface="Trebuchet MS" pitchFamily="34" charset="-120"/>
               </a:rPr>
-              <a:t>wake</a:t>
+              <a:t>way</a:t>
             </a:r>
             <a:endParaRPr lang="en-US" sz="1300" dirty="0"/>
           </a:p>
@@ -38234,7 +38362,7 @@
         </p:nvSpPr>
         <p:spPr>
           <a:xfrm>
-            <a:off x="3685032" y="4178808"/>
+            <a:off x="3557016" y="4178808"/>
             <a:ext cx="320040" cy="420624"/>
           </a:xfrm>
           <a:prstGeom prst="rect">
@@ -38273,7 +38401,7 @@
         </p:nvSpPr>
         <p:spPr>
           <a:xfrm>
-            <a:off x="4032504" y="4178808"/>
+            <a:off x="3904488" y="4178808"/>
             <a:ext cx="950976" cy="420624"/>
           </a:xfrm>
           <a:prstGeom prst="rect">
@@ -38307,7 +38435,7 @@
         </p:nvSpPr>
         <p:spPr>
           <a:xfrm>
-            <a:off x="4032504" y="4178808"/>
+            <a:off x="3904488" y="4178808"/>
             <a:ext cx="950976" cy="420624"/>
           </a:xfrm>
           <a:prstGeom prst="rect">
@@ -38346,7 +38474,7 @@
         </p:nvSpPr>
         <p:spPr>
           <a:xfrm>
-            <a:off x="5056632" y="4178808"/>
+            <a:off x="4928616" y="4178808"/>
             <a:ext cx="365760" cy="420624"/>
           </a:xfrm>
           <a:prstGeom prst="rect">
@@ -38385,7 +38513,7 @@
         </p:nvSpPr>
         <p:spPr>
           <a:xfrm>
-            <a:off x="5468112" y="4178808"/>
+            <a:off x="5340096" y="4178808"/>
             <a:ext cx="2194560" cy="420624"/>
           </a:xfrm>
           <a:prstGeom prst="rect">
@@ -38412,7 +38540,7 @@
         </p:nvSpPr>
         <p:spPr>
           <a:xfrm>
-            <a:off x="5468112" y="4178808"/>
+            <a:off x="5340096" y="4178808"/>
             <a:ext cx="2194560" cy="420624"/>
           </a:xfrm>
           <a:prstGeom prst="rect">
@@ -38729,7 +38857,7 @@
                 <a:ea typeface="Calibri" pitchFamily="34" charset="-122"/>
                 <a:cs typeface="Calibri" pitchFamily="34" charset="-120"/>
               </a:rPr>
-              <a:t>Word Labs  •  wordlabs.app  •  Prefix: 'a-' = on, in, or into a state</a:t>
+              <a:t>Word Labs  •  wordlabs.app  •  Prefix: 'a-' = not, without, on, toward</a:t>
             </a:r>
             <a:endParaRPr lang="en-US" sz="800" dirty="0"/>
           </a:p>
@@ -38907,7 +39035,7 @@
                 <a:ea typeface="Calibri" pitchFamily="34" charset="-122"/>
                 <a:cs typeface="Calibri" pitchFamily="34" charset="-120"/>
               </a:rPr>
-              <a:t>To one side; out of the way.</a:t>
+              <a:t>Away from the correct path or direction; lost.</a:t>
             </a:r>
             <a:endParaRPr lang="en-US" sz="1200" dirty="0"/>
           </a:p>
@@ -38980,7 +39108,7 @@
                 <a:ea typeface="Trebuchet MS" pitchFamily="34" charset="-122"/>
                 <a:cs typeface="Trebuchet MS" pitchFamily="34" charset="-120"/>
               </a:rPr>
-              <a:t>alive</a:t>
+              <a:t>ashore</a:t>
             </a:r>
             <a:endParaRPr lang="en-US" sz="1200" dirty="0"/>
           </a:p>
@@ -39046,7 +39174,7 @@
                 <a:ea typeface="Calibri" pitchFamily="34" charset="-122"/>
                 <a:cs typeface="Calibri" pitchFamily="34" charset="-120"/>
               </a:rPr>
-              <a:t>On or towards the land, away from the water.</a:t>
+              <a:t>High up in the air or in the sky.</a:t>
             </a:r>
             <a:endParaRPr lang="en-US" sz="1200" dirty="0"/>
           </a:p>
@@ -39185,7 +39313,7 @@
                 <a:ea typeface="Calibri" pitchFamily="34" charset="-122"/>
                 <a:cs typeface="Calibri" pitchFamily="34" charset="-120"/>
               </a:rPr>
-              <a:t>Using your voice so others can hear; not silent.</a:t>
+              <a:t>In progress or happening; also means on foot.</a:t>
             </a:r>
             <a:endParaRPr lang="en-US" sz="1200" dirty="0"/>
           </a:p>
@@ -39258,7 +39386,7 @@
                 <a:ea typeface="Trebuchet MS" pitchFamily="34" charset="-122"/>
                 <a:cs typeface="Trebuchet MS" pitchFamily="34" charset="-120"/>
               </a:rPr>
-              <a:t>ashore</a:t>
+              <a:t>aloft</a:t>
             </a:r>
             <a:endParaRPr lang="en-US" sz="1200" dirty="0"/>
           </a:p>
@@ -39324,7 +39452,7 @@
                 <a:ea typeface="Calibri" pitchFamily="34" charset="-122"/>
                 <a:cs typeface="Calibri" pitchFamily="34" charset="-120"/>
               </a:rPr>
-              <a:t>On or into a ship, plane, or other vehicle.</a:t>
+              <a:t>On or into a ship, train, plane, or other vehicle.</a:t>
             </a:r>
             <a:endParaRPr lang="en-US" sz="1200" dirty="0"/>
           </a:p>
@@ -39397,7 +39525,7 @@
                 <a:ea typeface="Trebuchet MS" pitchFamily="34" charset="-122"/>
                 <a:cs typeface="Trebuchet MS" pitchFamily="34" charset="-120"/>
               </a:rPr>
-              <a:t>aside</a:t>
+              <a:t>astray</a:t>
             </a:r>
             <a:endParaRPr lang="en-US" sz="1200" dirty="0"/>
           </a:p>
@@ -39463,7 +39591,7 @@
                 <a:ea typeface="Calibri" pitchFamily="34" charset="-122"/>
                 <a:cs typeface="Calibri" pitchFamily="34" charset="-120"/>
               </a:rPr>
-              <a:t>Floating on water; not sinking.</a:t>
+              <a:t>On fire; burning brightly with flames.</a:t>
             </a:r>
             <a:endParaRPr lang="en-US" sz="1200" dirty="0"/>
           </a:p>
@@ -39536,7 +39664,7 @@
                 <a:ea typeface="Trebuchet MS" pitchFamily="34" charset="-122"/>
                 <a:cs typeface="Trebuchet MS" pitchFamily="34" charset="-120"/>
               </a:rPr>
-              <a:t>aloud</a:t>
+              <a:t>afoot</a:t>
             </a:r>
             <a:endParaRPr lang="en-US" sz="1200" dirty="0"/>
           </a:p>
@@ -39602,7 +39730,7 @@
                 <a:ea typeface="Calibri" pitchFamily="34" charset="-122"/>
                 <a:cs typeface="Calibri" pitchFamily="34" charset="-120"/>
               </a:rPr>
-              <a:t>Not asleep; fully conscious and aware of your surroundings.</a:t>
+              <a:t>Not asleep; fully conscious and alert.</a:t>
             </a:r>
             <a:endParaRPr lang="en-US" sz="1200" dirty="0"/>
           </a:p>
@@ -39675,7 +39803,7 @@
                 <a:ea typeface="Trebuchet MS" pitchFamily="34" charset="-122"/>
                 <a:cs typeface="Trebuchet MS" pitchFamily="34" charset="-120"/>
               </a:rPr>
-              <a:t>afloat</a:t>
+              <a:t>ablaze</a:t>
             </a:r>
             <a:endParaRPr lang="en-US" sz="1200" dirty="0"/>
           </a:p>
@@ -39741,7 +39869,7 @@
                 <a:ea typeface="Calibri" pitchFamily="34" charset="-122"/>
                 <a:cs typeface="Calibri" pitchFamily="34" charset="-120"/>
               </a:rPr>
-              <a:t>Living and breathing; not dead.</a:t>
+              <a:t>On or toward the shore or land, especially after being at sea.</a:t>
             </a:r>
             <a:endParaRPr lang="en-US" sz="1200" dirty="0"/>
           </a:p>
@@ -40033,7 +40161,7 @@
                 <a:ea typeface="Calibri" pitchFamily="34" charset="-122"/>
                 <a:cs typeface="Calibri" pitchFamily="34" charset="-120"/>
               </a:rPr>
-              <a:t>Word Labs  •  wordlabs.app  •  Prefix: 'a-' = on, in, or into a state</a:t>
+              <a:t>Word Labs  •  wordlabs.app  •  Prefix: 'a-' = not, without, on, toward</a:t>
             </a:r>
             <a:endParaRPr lang="en-US" sz="800" dirty="0"/>
           </a:p>
@@ -40236,7 +40364,7 @@
                 <a:ea typeface="Calibri" pitchFamily="34" charset="-122"/>
                 <a:cs typeface="Calibri" pitchFamily="34" charset="-120"/>
               </a:rPr>
-              <a:t>The children stayed awake all night listening to the storm outside.</a:t>
+              <a:t>The sailor climbed aboard the tall sailing ship before sunrise.</a:t>
             </a:r>
             <a:endParaRPr lang="en-US" sz="1500" dirty="0"/>
           </a:p>
@@ -40400,7 +40528,7 @@
                 <a:ea typeface="Calibri" pitchFamily="34" charset="-122"/>
                 <a:cs typeface="Calibri" pitchFamily="34" charset="-120"/>
               </a:rPr>
-              <a:t>We climbed aboard the ferry and found seats near the window.</a:t>
+              <a:t>The dry bush was ablaze after lightning struck the old gum tree.</a:t>
             </a:r>
             <a:endParaRPr lang="en-US" sz="1500" dirty="0"/>
           </a:p>
@@ -40564,7 +40692,7 @@
                 <a:ea typeface="Calibri" pitchFamily="34" charset="-122"/>
                 <a:cs typeface="Calibri" pitchFamily="34" charset="-120"/>
               </a:rPr>
-              <a:t>The injured bird was still alive when we found it in the garden.</a:t>
+              <a:t>The lost puppy had gone astray in the park near our school.</a:t>
             </a:r>
             <a:endParaRPr lang="en-US" sz="1500" dirty="0"/>
           </a:p>

</xml_diff>